<commit_message>
Update slides: add simulator screenshot slide and integration references
</commit_message>
<xml_diff>
--- a/slides.pptx
+++ b/slides.pptx
@@ -5,7 +5,7 @@
     <p:sldMasterId id="2147483648" r:id="rId1"/>
   </p:sldMasterIdLst>
   <p:notesMasterIdLst>
-    <p:notesMasterId r:id="rId15"/>
+    <p:notesMasterId r:id="rId16"/>
   </p:notesMasterIdLst>
   <p:sldIdLst>
     <p:sldId id="256" r:id="rId2"/>
@@ -13,14 +13,15 @@
     <p:sldId id="258" r:id="rId4"/>
     <p:sldId id="259" r:id="rId5"/>
     <p:sldId id="260" r:id="rId6"/>
-    <p:sldId id="261" r:id="rId7"/>
-    <p:sldId id="262" r:id="rId8"/>
-    <p:sldId id="263" r:id="rId9"/>
-    <p:sldId id="264" r:id="rId10"/>
-    <p:sldId id="265" r:id="rId11"/>
-    <p:sldId id="266" r:id="rId12"/>
-    <p:sldId id="268" r:id="rId13"/>
-    <p:sldId id="269" r:id="rId14"/>
+    <p:sldId id="270" r:id="rId7"/>
+    <p:sldId id="261" r:id="rId8"/>
+    <p:sldId id="262" r:id="rId9"/>
+    <p:sldId id="263" r:id="rId10"/>
+    <p:sldId id="264" r:id="rId11"/>
+    <p:sldId id="265" r:id="rId12"/>
+    <p:sldId id="266" r:id="rId13"/>
+    <p:sldId id="268" r:id="rId14"/>
+    <p:sldId id="269" r:id="rId15"/>
   </p:sldIdLst>
   <p:sldSz cx="9144000" cy="5143500" type="screen16x9"/>
   <p:notesSz cx="5143500" cy="9144000"/>
@@ -669,6 +670,90 @@
 </p:notes>
 </file>
 
+<file path=ppt/notesSlides/notesSlide14.xml><?xml version="1.0" encoding="utf-8"?>
+<p:notes xmlns:a="http://schemas.openxmlformats.org/drawingml/2006/main" xmlns:r="http://schemas.openxmlformats.org/officeDocument/2006/relationships" xmlns:p="http://schemas.openxmlformats.org/presentationml/2006/main">
+  <p:cSld>
+    <p:spTree>
+      <p:nvGrpSpPr>
+        <p:cNvPr id="1" name=""/>
+        <p:cNvGrpSpPr/>
+        <p:nvPr/>
+      </p:nvGrpSpPr>
+      <p:grpSpPr>
+        <a:xfrm>
+          <a:off x="0" y="0"/>
+          <a:ext cx="0" cy="0"/>
+          <a:chOff x="0" y="0"/>
+          <a:chExt cx="0" cy="0"/>
+        </a:xfrm>
+      </p:grpSpPr>
+      <p:sp>
+        <p:nvSpPr>
+          <p:cNvPr id="2" name="Slide Image Placeholder 1"/>
+          <p:cNvSpPr>
+            <a:spLocks noGrp="1" noRot="1" noChangeAspect="1"/>
+          </p:cNvSpPr>
+          <p:nvPr>
+            <p:ph type="sldImg"/>
+          </p:nvPr>
+        </p:nvSpPr>
+        <p:spPr/>
+      </p:sp>
+      <p:sp>
+        <p:nvSpPr>
+          <p:cNvPr id="3" name="Notes Placeholder 2"/>
+          <p:cNvSpPr>
+            <a:spLocks noGrp="1"/>
+          </p:cNvSpPr>
+          <p:nvPr>
+            <p:ph type="body" idx="1"/>
+          </p:nvPr>
+        </p:nvSpPr>
+        <p:spPr/>
+        <p:txBody>
+          <a:bodyPr/>
+          <a:lstStyle/>
+          <a:p>
+            <a:endParaRPr lang="en-US" dirty="0"/>
+          </a:p>
+        </p:txBody>
+      </p:sp>
+      <p:sp>
+        <p:nvSpPr>
+          <p:cNvPr id="4" name="Slide Number Placeholder 3"/>
+          <p:cNvSpPr>
+            <a:spLocks noGrp="1"/>
+          </p:cNvSpPr>
+          <p:nvPr>
+            <p:ph type="sldNum" sz="quarter" idx="10"/>
+          </p:nvPr>
+        </p:nvSpPr>
+        <p:spPr/>
+        <p:txBody>
+          <a:bodyPr/>
+          <a:lstStyle/>
+          <a:p>
+            <a:fld id="{F7021451-1387-4CA6-816F-3879F97B5CBC}" type="slidenum">
+              <a:rPr lang="en-US"/>
+              <a:t>14</a:t>
+            </a:fld>
+            <a:endParaRPr lang="en-US"/>
+          </a:p>
+        </p:txBody>
+      </p:sp>
+    </p:spTree>
+    <p:extLst>
+      <p:ext uri="{BB962C8B-B14F-4D97-AF65-F5344CB8AC3E}">
+        <p14:creationId xmlns:p14="http://schemas.microsoft.com/office/powerpoint/2010/main" val="1024086991"/>
+      </p:ext>
+    </p:extLst>
+  </p:cSld>
+  <p:clrMapOvr>
+    <a:masterClrMapping/>
+  </p:clrMapOvr>
+</p:notes>
+</file>
+
 <file path=ppt/notesSlides/notesSlide2.xml><?xml version="1.0" encoding="utf-8"?>
 <p:notes xmlns:a="http://schemas.openxmlformats.org/drawingml/2006/main" xmlns:r="http://schemas.openxmlformats.org/officeDocument/2006/relationships" xmlns:p="http://schemas.openxmlformats.org/presentationml/2006/main">
   <p:cSld>
@@ -1010,7 +1095,13 @@
   <p:cSld>
     <p:spTree>
       <p:nvGrpSpPr>
-        <p:cNvPr id="1" name=""/>
+        <p:cNvPr id="1" name="">
+          <a:extLst>
+            <a:ext uri="{FF2B5EF4-FFF2-40B4-BE49-F238E27FC236}">
+              <a16:creationId xmlns:a16="http://schemas.microsoft.com/office/drawing/2014/main" id="{27E2DAF9-D286-A3C6-612E-4B35340E70FD}"/>
+            </a:ext>
+          </a:extLst>
+        </p:cNvPr>
         <p:cNvGrpSpPr/>
         <p:nvPr/>
       </p:nvGrpSpPr>
@@ -1024,7 +1115,13 @@
       </p:grpSpPr>
       <p:sp>
         <p:nvSpPr>
-          <p:cNvPr id="2" name="Slide Image Placeholder 1"/>
+          <p:cNvPr id="2" name="Slide Image Placeholder 1">
+            <a:extLst>
+              <a:ext uri="{FF2B5EF4-FFF2-40B4-BE49-F238E27FC236}">
+                <a16:creationId xmlns:a16="http://schemas.microsoft.com/office/drawing/2014/main" id="{DB103D98-C81B-65FF-76EE-3075E9749A8A}"/>
+              </a:ext>
+            </a:extLst>
+          </p:cNvPr>
           <p:cNvSpPr>
             <a:spLocks noGrp="1" noRot="1" noChangeAspect="1"/>
           </p:cNvSpPr>
@@ -1036,7 +1133,13 @@
       </p:sp>
       <p:sp>
         <p:nvSpPr>
-          <p:cNvPr id="3" name="Notes Placeholder 2"/>
+          <p:cNvPr id="3" name="Notes Placeholder 2">
+            <a:extLst>
+              <a:ext uri="{FF2B5EF4-FFF2-40B4-BE49-F238E27FC236}">
+                <a16:creationId xmlns:a16="http://schemas.microsoft.com/office/drawing/2014/main" id="{DC089D33-E90D-ABF1-89FF-380368B415A0}"/>
+              </a:ext>
+            </a:extLst>
+          </p:cNvPr>
           <p:cNvSpPr>
             <a:spLocks noGrp="1"/>
           </p:cNvSpPr>
@@ -1055,7 +1158,13 @@
       </p:sp>
       <p:sp>
         <p:nvSpPr>
-          <p:cNvPr id="4" name="Slide Number Placeholder 3"/>
+          <p:cNvPr id="4" name="Slide Number Placeholder 3">
+            <a:extLst>
+              <a:ext uri="{FF2B5EF4-FFF2-40B4-BE49-F238E27FC236}">
+                <a16:creationId xmlns:a16="http://schemas.microsoft.com/office/drawing/2014/main" id="{8C36ACF8-3E0A-9FFF-5A60-334ED0C73A96}"/>
+              </a:ext>
+            </a:extLst>
+          </p:cNvPr>
           <p:cNvSpPr>
             <a:spLocks noGrp="1"/>
           </p:cNvSpPr>
@@ -1079,7 +1188,7 @@
     </p:spTree>
     <p:extLst>
       <p:ext uri="{BB962C8B-B14F-4D97-AF65-F5344CB8AC3E}">
-        <p14:creationId xmlns:p14="http://schemas.microsoft.com/office/powerpoint/2010/main" val="1024086991"/>
+        <p14:creationId xmlns:p14="http://schemas.microsoft.com/office/powerpoint/2010/main" val="4081123010"/>
       </p:ext>
     </p:extLst>
   </p:cSld>
@@ -1967,6 +2076,882 @@
 
 <file path=ppt/slides/slide10.xml><?xml version="1.0" encoding="utf-8"?>
 <p:sld xmlns:a="http://schemas.openxmlformats.org/drawingml/2006/main" xmlns:r="http://schemas.openxmlformats.org/officeDocument/2006/relationships" xmlns:p="http://schemas.openxmlformats.org/presentationml/2006/main">
+  <p:cSld name="Slide 9">
+    <p:bg>
+      <p:bgPr>
+        <a:solidFill>
+          <a:srgbClr val="0A1628"/>
+        </a:solidFill>
+        <a:effectLst/>
+      </p:bgPr>
+    </p:bg>
+    <p:spTree>
+      <p:nvGrpSpPr>
+        <p:cNvPr id="1" name=""/>
+        <p:cNvGrpSpPr/>
+        <p:nvPr/>
+      </p:nvGrpSpPr>
+      <p:grpSpPr>
+        <a:xfrm>
+          <a:off x="0" y="0"/>
+          <a:ext cx="0" cy="0"/>
+          <a:chOff x="0" y="0"/>
+          <a:chExt cx="0" cy="0"/>
+        </a:xfrm>
+      </p:grpSpPr>
+      <p:sp>
+        <p:nvSpPr>
+          <p:cNvPr id="2" name="Text 0"/>
+          <p:cNvSpPr/>
+          <p:nvPr/>
+        </p:nvSpPr>
+        <p:spPr>
+          <a:xfrm>
+            <a:off x="365760" y="137160"/>
+            <a:ext cx="4114800" cy="548640"/>
+          </a:xfrm>
+          <a:prstGeom prst="rect">
+            <a:avLst/>
+          </a:prstGeom>
+          <a:noFill/>
+          <a:ln/>
+        </p:spPr>
+        <p:txBody>
+          <a:bodyPr wrap="square" rtlCol="0" anchor="ctr"/>
+          <a:lstStyle/>
+          <a:p>
+            <a:pPr marL="0" indent="0">
+              <a:buNone/>
+            </a:pPr>
+            <a:r>
+              <a:rPr lang="en-US" sz="1200" kern="0" spc="300" dirty="0">
+                <a:solidFill>
+                  <a:srgbClr val="00C2CB"/>
+                </a:solidFill>
+                <a:latin typeface="Calibri" pitchFamily="34" charset="0"/>
+                <a:ea typeface="Calibri" pitchFamily="34" charset="-122"/>
+                <a:cs typeface="Calibri" pitchFamily="34" charset="-120"/>
+              </a:rPr>
+              <a:t>Real-World Case Study</a:t>
+            </a:r>
+            <a:endParaRPr lang="en-US" sz="1200" dirty="0"/>
+          </a:p>
+        </p:txBody>
+      </p:sp>
+      <p:sp>
+        <p:nvSpPr>
+          <p:cNvPr id="3" name="Text 1"/>
+          <p:cNvSpPr/>
+          <p:nvPr/>
+        </p:nvSpPr>
+        <p:spPr>
+          <a:xfrm>
+            <a:off x="365760" y="502920"/>
+            <a:ext cx="8412480" cy="777240"/>
+          </a:xfrm>
+          <a:prstGeom prst="rect">
+            <a:avLst/>
+          </a:prstGeom>
+          <a:noFill/>
+          <a:ln/>
+        </p:spPr>
+        <p:txBody>
+          <a:bodyPr wrap="square" rtlCol="0" anchor="ctr"/>
+          <a:lstStyle/>
+          <a:p>
+            <a:pPr marL="0" indent="0">
+              <a:buNone/>
+            </a:pPr>
+            <a:r>
+              <a:rPr lang="en-US" sz="2200" b="1" dirty="0">
+                <a:solidFill>
+                  <a:srgbClr val="FFFFFF"/>
+                </a:solidFill>
+                <a:latin typeface="Calibri" pitchFamily="34" charset="0"/>
+                <a:ea typeface="Calibri" pitchFamily="34" charset="-122"/>
+                <a:cs typeface="Calibri" pitchFamily="34" charset="-120"/>
+              </a:rPr>
+              <a:t>Kernels in Action: Self-Driving Cars, Medical AI &amp; Mobile Vision</a:t>
+            </a:r>
+            <a:endParaRPr lang="en-US" sz="2200" dirty="0"/>
+          </a:p>
+        </p:txBody>
+      </p:sp>
+      <p:sp>
+        <p:nvSpPr>
+          <p:cNvPr id="4" name="Shape 2"/>
+          <p:cNvSpPr/>
+          <p:nvPr/>
+        </p:nvSpPr>
+        <p:spPr>
+          <a:xfrm>
+            <a:off x="274321" y="1227937"/>
+            <a:ext cx="8641079" cy="64193"/>
+          </a:xfrm>
+          <a:prstGeom prst="rect">
+            <a:avLst/>
+          </a:prstGeom>
+          <a:solidFill>
+            <a:srgbClr val="00C2CB"/>
+          </a:solidFill>
+          <a:ln/>
+        </p:spPr>
+        <p:txBody>
+          <a:bodyPr/>
+          <a:lstStyle/>
+          <a:p>
+            <a:endParaRPr lang="en-MT"/>
+          </a:p>
+        </p:txBody>
+      </p:sp>
+      <p:sp>
+        <p:nvSpPr>
+          <p:cNvPr id="5" name="Shape 3"/>
+          <p:cNvSpPr/>
+          <p:nvPr/>
+        </p:nvSpPr>
+        <p:spPr>
+          <a:xfrm>
+            <a:off x="274321" y="1417320"/>
+            <a:ext cx="2697480" cy="3474720"/>
+          </a:xfrm>
+          <a:prstGeom prst="rect">
+            <a:avLst/>
+          </a:prstGeom>
+          <a:solidFill>
+            <a:srgbClr val="122040"/>
+          </a:solidFill>
+          <a:ln/>
+          <a:effectLst>
+            <a:outerShdw blurRad="101600" dist="38100" dir="8100000" algn="bl" rotWithShape="0">
+              <a:srgbClr val="000000">
+                <a:alpha val="18000"/>
+              </a:srgbClr>
+            </a:outerShdw>
+          </a:effectLst>
+        </p:spPr>
+        <p:txBody>
+          <a:bodyPr/>
+          <a:lstStyle/>
+          <a:p>
+            <a:endParaRPr lang="en-MT"/>
+          </a:p>
+        </p:txBody>
+      </p:sp>
+      <p:grpSp>
+        <p:nvGrpSpPr>
+          <p:cNvPr id="27" name="Group 26">
+            <a:extLst>
+              <a:ext uri="{FF2B5EF4-FFF2-40B4-BE49-F238E27FC236}">
+                <a16:creationId xmlns:a16="http://schemas.microsoft.com/office/drawing/2014/main" id="{420B0913-8DEE-B7C5-9F84-C3E3E88E5A54}"/>
+              </a:ext>
+            </a:extLst>
+          </p:cNvPr>
+          <p:cNvGrpSpPr/>
+          <p:nvPr/>
+        </p:nvGrpSpPr>
+        <p:grpSpPr>
+          <a:xfrm>
+            <a:off x="274320" y="1417320"/>
+            <a:ext cx="2697480" cy="3337560"/>
+            <a:chOff x="274320" y="1417320"/>
+            <a:chExt cx="2697480" cy="3337560"/>
+          </a:xfrm>
+        </p:grpSpPr>
+        <p:sp>
+          <p:nvSpPr>
+            <p:cNvPr id="6" name="Shape 4"/>
+            <p:cNvSpPr/>
+            <p:nvPr/>
+          </p:nvSpPr>
+          <p:spPr>
+            <a:xfrm>
+              <a:off x="274320" y="1417320"/>
+              <a:ext cx="2697480" cy="82296"/>
+            </a:xfrm>
+            <a:prstGeom prst="rect">
+              <a:avLst/>
+            </a:prstGeom>
+            <a:solidFill>
+              <a:srgbClr val="E84545"/>
+            </a:solidFill>
+            <a:ln/>
+          </p:spPr>
+          <p:txBody>
+            <a:bodyPr/>
+            <a:lstStyle/>
+            <a:p>
+              <a:endParaRPr lang="en-MT"/>
+            </a:p>
+          </p:txBody>
+        </p:sp>
+        <p:pic>
+          <p:nvPicPr>
+            <p:cNvPr id="7" name="Image 0" descr="preencoded.png"/>
+            <p:cNvPicPr>
+              <a:picLocks noChangeAspect="1"/>
+            </p:cNvPicPr>
+            <p:nvPr/>
+          </p:nvPicPr>
+          <p:blipFill>
+            <a:blip r:embed="rId3"/>
+            <a:stretch>
+              <a:fillRect/>
+            </a:stretch>
+          </p:blipFill>
+          <p:spPr>
+            <a:xfrm>
+              <a:off x="428652" y="1628895"/>
+              <a:ext cx="411480" cy="411480"/>
+            </a:xfrm>
+            <a:prstGeom prst="rect">
+              <a:avLst/>
+            </a:prstGeom>
+          </p:spPr>
+        </p:pic>
+        <p:sp>
+          <p:nvSpPr>
+            <p:cNvPr id="8" name="Text 5"/>
+            <p:cNvSpPr/>
+            <p:nvPr/>
+          </p:nvSpPr>
+          <p:spPr>
+            <a:xfrm>
+              <a:off x="868680" y="1554480"/>
+              <a:ext cx="2103120" cy="274320"/>
+            </a:xfrm>
+            <a:prstGeom prst="rect">
+              <a:avLst/>
+            </a:prstGeom>
+            <a:noFill/>
+            <a:ln/>
+          </p:spPr>
+          <p:txBody>
+            <a:bodyPr wrap="square" rtlCol="0" anchor="ctr"/>
+            <a:lstStyle/>
+            <a:p>
+              <a:pPr marL="0" indent="0">
+                <a:buNone/>
+              </a:pPr>
+              <a:r>
+                <a:rPr lang="en-US" sz="1300" b="1" dirty="0">
+                  <a:solidFill>
+                    <a:srgbClr val="FFFFFF"/>
+                  </a:solidFill>
+                  <a:latin typeface="Calibri" pitchFamily="34" charset="0"/>
+                  <a:ea typeface="Calibri" pitchFamily="34" charset="-122"/>
+                  <a:cs typeface="Calibri" pitchFamily="34" charset="-120"/>
+                </a:rPr>
+                <a:t>Tesla Autopilot</a:t>
+              </a:r>
+              <a:endParaRPr lang="en-US" sz="1300" dirty="0"/>
+            </a:p>
+          </p:txBody>
+        </p:sp>
+        <p:sp>
+          <p:nvSpPr>
+            <p:cNvPr id="9" name="Text 6"/>
+            <p:cNvSpPr/>
+            <p:nvPr/>
+          </p:nvSpPr>
+          <p:spPr>
+            <a:xfrm>
+              <a:off x="868680" y="1847088"/>
+              <a:ext cx="2103120" cy="228600"/>
+            </a:xfrm>
+            <a:prstGeom prst="rect">
+              <a:avLst/>
+            </a:prstGeom>
+            <a:noFill/>
+            <a:ln/>
+          </p:spPr>
+          <p:txBody>
+            <a:bodyPr wrap="square" rtlCol="0" anchor="ctr"/>
+            <a:lstStyle/>
+            <a:p>
+              <a:pPr marL="0" indent="0">
+                <a:buNone/>
+              </a:pPr>
+              <a:r>
+                <a:rPr lang="en-US" sz="1000" i="1" dirty="0">
+                  <a:solidFill>
+                    <a:srgbClr val="E84545"/>
+                  </a:solidFill>
+                  <a:latin typeface="Calibri" pitchFamily="34" charset="0"/>
+                  <a:ea typeface="Calibri" pitchFamily="34" charset="-122"/>
+                  <a:cs typeface="Calibri" pitchFamily="34" charset="-120"/>
+                </a:rPr>
+                <a:t>Dilated Convolutions</a:t>
+              </a:r>
+              <a:endParaRPr lang="en-US" sz="1000" dirty="0"/>
+            </a:p>
+          </p:txBody>
+        </p:sp>
+        <p:sp>
+          <p:nvSpPr>
+            <p:cNvPr id="10" name="Shape 7"/>
+            <p:cNvSpPr/>
+            <p:nvPr/>
+          </p:nvSpPr>
+          <p:spPr>
+            <a:xfrm>
+              <a:off x="411480" y="2148839"/>
+              <a:ext cx="2450666" cy="45719"/>
+            </a:xfrm>
+            <a:prstGeom prst="rect">
+              <a:avLst/>
+            </a:prstGeom>
+            <a:solidFill>
+              <a:srgbClr val="E84545"/>
+            </a:solidFill>
+            <a:ln/>
+          </p:spPr>
+          <p:txBody>
+            <a:bodyPr/>
+            <a:lstStyle/>
+            <a:p>
+              <a:endParaRPr lang="en-MT"/>
+            </a:p>
+          </p:txBody>
+        </p:sp>
+        <p:sp>
+          <p:nvSpPr>
+            <p:cNvPr id="11" name="Text 8"/>
+            <p:cNvSpPr/>
+            <p:nvPr/>
+          </p:nvSpPr>
+          <p:spPr>
+            <a:xfrm>
+              <a:off x="411480" y="2240280"/>
+              <a:ext cx="2383759" cy="2514600"/>
+            </a:xfrm>
+            <a:prstGeom prst="rect">
+              <a:avLst/>
+            </a:prstGeom>
+            <a:noFill/>
+            <a:ln/>
+          </p:spPr>
+          <p:txBody>
+            <a:bodyPr wrap="square" rtlCol="0" anchor="t"/>
+            <a:lstStyle/>
+            <a:p>
+              <a:pPr marL="0" indent="0">
+                <a:buNone/>
+              </a:pPr>
+              <a:r>
+                <a:rPr lang="en-US" sz="1100" dirty="0">
+                  <a:solidFill>
+                    <a:srgbClr val="E8F4F8"/>
+                  </a:solidFill>
+                  <a:latin typeface="Calibri" pitchFamily="34" charset="0"/>
+                  <a:ea typeface="Calibri" pitchFamily="34" charset="-122"/>
+                  <a:cs typeface="Calibri" pitchFamily="34" charset="-120"/>
+                </a:rPr>
+                <a:t>Dilated kernels (d=2,4,8) give the CNN a wide-angle view of the road without downsampling. The same 3×3 filter effectively sees a 15×15 area — crucial for detecting distant pedestrians while preserving lane-marking detail.</a:t>
+              </a:r>
+              <a:endParaRPr lang="en-US" sz="1100" dirty="0"/>
+            </a:p>
+          </p:txBody>
+        </p:sp>
+      </p:grpSp>
+      <p:sp>
+        <p:nvSpPr>
+          <p:cNvPr id="12" name="Shape 9"/>
+          <p:cNvSpPr/>
+          <p:nvPr/>
+        </p:nvSpPr>
+        <p:spPr>
+          <a:xfrm>
+            <a:off x="3246120" y="1417320"/>
+            <a:ext cx="2697480" cy="3474720"/>
+          </a:xfrm>
+          <a:prstGeom prst="rect">
+            <a:avLst/>
+          </a:prstGeom>
+          <a:solidFill>
+            <a:srgbClr val="122040"/>
+          </a:solidFill>
+          <a:ln/>
+          <a:effectLst>
+            <a:outerShdw blurRad="101600" dist="38100" dir="8100000" algn="bl" rotWithShape="0">
+              <a:srgbClr val="000000">
+                <a:alpha val="18000"/>
+              </a:srgbClr>
+            </a:outerShdw>
+          </a:effectLst>
+        </p:spPr>
+        <p:txBody>
+          <a:bodyPr/>
+          <a:lstStyle/>
+          <a:p>
+            <a:endParaRPr lang="en-MT"/>
+          </a:p>
+        </p:txBody>
+      </p:sp>
+      <p:sp>
+        <p:nvSpPr>
+          <p:cNvPr id="13" name="Shape 10"/>
+          <p:cNvSpPr/>
+          <p:nvPr/>
+        </p:nvSpPr>
+        <p:spPr>
+          <a:xfrm>
+            <a:off x="3246120" y="1417320"/>
+            <a:ext cx="2697480" cy="82296"/>
+          </a:xfrm>
+          <a:prstGeom prst="rect">
+            <a:avLst/>
+          </a:prstGeom>
+          <a:solidFill>
+            <a:srgbClr val="00A896"/>
+          </a:solidFill>
+          <a:ln/>
+        </p:spPr>
+        <p:txBody>
+          <a:bodyPr/>
+          <a:lstStyle/>
+          <a:p>
+            <a:endParaRPr lang="en-MT"/>
+          </a:p>
+        </p:txBody>
+      </p:sp>
+      <p:pic>
+        <p:nvPicPr>
+          <p:cNvPr id="14" name="Image 1" descr="preencoded.png"/>
+          <p:cNvPicPr>
+            <a:picLocks noChangeAspect="1"/>
+          </p:cNvPicPr>
+          <p:nvPr/>
+        </p:nvPicPr>
+        <p:blipFill>
+          <a:blip r:embed="rId4"/>
+          <a:stretch>
+            <a:fillRect/>
+          </a:stretch>
+        </p:blipFill>
+        <p:spPr>
+          <a:xfrm>
+            <a:off x="3419891" y="1613915"/>
+            <a:ext cx="411480" cy="411480"/>
+          </a:xfrm>
+          <a:prstGeom prst="rect">
+            <a:avLst/>
+          </a:prstGeom>
+        </p:spPr>
+      </p:pic>
+      <p:sp>
+        <p:nvSpPr>
+          <p:cNvPr id="15" name="Text 11"/>
+          <p:cNvSpPr/>
+          <p:nvPr/>
+        </p:nvSpPr>
+        <p:spPr>
+          <a:xfrm>
+            <a:off x="3840480" y="1554480"/>
+            <a:ext cx="2103120" cy="274320"/>
+          </a:xfrm>
+          <a:prstGeom prst="rect">
+            <a:avLst/>
+          </a:prstGeom>
+          <a:noFill/>
+          <a:ln/>
+        </p:spPr>
+        <p:txBody>
+          <a:bodyPr wrap="square" rtlCol="0" anchor="ctr"/>
+          <a:lstStyle/>
+          <a:p>
+            <a:pPr marL="0" indent="0">
+              <a:buNone/>
+            </a:pPr>
+            <a:r>
+              <a:rPr lang="en-US" sz="1300" b="1" dirty="0">
+                <a:solidFill>
+                  <a:srgbClr val="FFFFFF"/>
+                </a:solidFill>
+                <a:latin typeface="Calibri" pitchFamily="34" charset="0"/>
+                <a:ea typeface="Calibri" pitchFamily="34" charset="-122"/>
+                <a:cs typeface="Calibri" pitchFamily="34" charset="-120"/>
+              </a:rPr>
+              <a:t>Medical Imaging</a:t>
+            </a:r>
+            <a:endParaRPr lang="en-US" sz="1300" dirty="0"/>
+          </a:p>
+        </p:txBody>
+      </p:sp>
+      <p:sp>
+        <p:nvSpPr>
+          <p:cNvPr id="16" name="Text 12"/>
+          <p:cNvSpPr/>
+          <p:nvPr/>
+        </p:nvSpPr>
+        <p:spPr>
+          <a:xfrm>
+            <a:off x="3840480" y="1847088"/>
+            <a:ext cx="2103120" cy="228600"/>
+          </a:xfrm>
+          <a:prstGeom prst="rect">
+            <a:avLst/>
+          </a:prstGeom>
+          <a:noFill/>
+          <a:ln/>
+        </p:spPr>
+        <p:txBody>
+          <a:bodyPr wrap="square" rtlCol="0" anchor="ctr"/>
+          <a:lstStyle/>
+          <a:p>
+            <a:pPr marL="0" indent="0">
+              <a:buNone/>
+            </a:pPr>
+            <a:r>
+              <a:rPr lang="en-US" sz="1000" i="1" dirty="0">
+                <a:solidFill>
+                  <a:srgbClr val="00A896"/>
+                </a:solidFill>
+                <a:latin typeface="Calibri" pitchFamily="34" charset="0"/>
+                <a:ea typeface="Calibri" pitchFamily="34" charset="-122"/>
+                <a:cs typeface="Calibri" pitchFamily="34" charset="-120"/>
+              </a:rPr>
+              <a:t>Sobel + U-Net</a:t>
+            </a:r>
+            <a:endParaRPr lang="en-US" sz="1000" dirty="0"/>
+          </a:p>
+        </p:txBody>
+      </p:sp>
+      <p:sp>
+        <p:nvSpPr>
+          <p:cNvPr id="17" name="Shape 13"/>
+          <p:cNvSpPr/>
+          <p:nvPr/>
+        </p:nvSpPr>
+        <p:spPr>
+          <a:xfrm>
+            <a:off x="3383280" y="2148839"/>
+            <a:ext cx="2422788" cy="45719"/>
+          </a:xfrm>
+          <a:prstGeom prst="rect">
+            <a:avLst/>
+          </a:prstGeom>
+          <a:solidFill>
+            <a:srgbClr val="00A896"/>
+          </a:solidFill>
+          <a:ln/>
+        </p:spPr>
+        <p:txBody>
+          <a:bodyPr/>
+          <a:lstStyle/>
+          <a:p>
+            <a:endParaRPr lang="en-MT"/>
+          </a:p>
+        </p:txBody>
+      </p:sp>
+      <p:sp>
+        <p:nvSpPr>
+          <p:cNvPr id="18" name="Text 14"/>
+          <p:cNvSpPr/>
+          <p:nvPr/>
+        </p:nvSpPr>
+        <p:spPr>
+          <a:xfrm>
+            <a:off x="3383280" y="2240280"/>
+            <a:ext cx="2288974" cy="2514600"/>
+          </a:xfrm>
+          <a:prstGeom prst="rect">
+            <a:avLst/>
+          </a:prstGeom>
+          <a:noFill/>
+          <a:ln/>
+        </p:spPr>
+        <p:txBody>
+          <a:bodyPr wrap="square" rtlCol="0" anchor="t"/>
+          <a:lstStyle/>
+          <a:p>
+            <a:pPr marL="0" indent="0">
+              <a:buNone/>
+            </a:pPr>
+            <a:r>
+              <a:rPr lang="en-US" sz="1100" dirty="0">
+                <a:solidFill>
+                  <a:srgbClr val="E8F4F8"/>
+                </a:solidFill>
+                <a:latin typeface="Calibri" pitchFamily="34" charset="0"/>
+                <a:ea typeface="Calibri" pitchFamily="34" charset="-122"/>
+                <a:cs typeface="Calibri" pitchFamily="34" charset="-120"/>
+              </a:rPr>
+              <a:t>Radiologists use Sobel-seeded CNNs to segment tumour boundaries in MRI scans. The Laplacian kernel highlights micro-textures invisible to the human eye, enabling earlier cancer detection at sub-millimetre precision.</a:t>
+            </a:r>
+            <a:endParaRPr lang="en-US" sz="1100" dirty="0"/>
+          </a:p>
+        </p:txBody>
+      </p:sp>
+      <p:sp>
+        <p:nvSpPr>
+          <p:cNvPr id="19" name="Shape 15"/>
+          <p:cNvSpPr/>
+          <p:nvPr/>
+        </p:nvSpPr>
+        <p:spPr>
+          <a:xfrm>
+            <a:off x="6217920" y="1417320"/>
+            <a:ext cx="2697480" cy="3474720"/>
+          </a:xfrm>
+          <a:prstGeom prst="rect">
+            <a:avLst/>
+          </a:prstGeom>
+          <a:solidFill>
+            <a:srgbClr val="122040"/>
+          </a:solidFill>
+          <a:ln/>
+          <a:effectLst>
+            <a:outerShdw blurRad="101600" dist="38100" dir="8100000" algn="bl" rotWithShape="0">
+              <a:srgbClr val="000000">
+                <a:alpha val="18000"/>
+              </a:srgbClr>
+            </a:outerShdw>
+          </a:effectLst>
+        </p:spPr>
+        <p:txBody>
+          <a:bodyPr/>
+          <a:lstStyle/>
+          <a:p>
+            <a:endParaRPr lang="en-MT"/>
+          </a:p>
+        </p:txBody>
+      </p:sp>
+      <p:sp>
+        <p:nvSpPr>
+          <p:cNvPr id="20" name="Shape 16"/>
+          <p:cNvSpPr/>
+          <p:nvPr/>
+        </p:nvSpPr>
+        <p:spPr>
+          <a:xfrm>
+            <a:off x="6217920" y="1417320"/>
+            <a:ext cx="2697480" cy="82296"/>
+          </a:xfrm>
+          <a:prstGeom prst="rect">
+            <a:avLst/>
+          </a:prstGeom>
+          <a:solidFill>
+            <a:srgbClr val="F5A623"/>
+          </a:solidFill>
+          <a:ln/>
+        </p:spPr>
+        <p:txBody>
+          <a:bodyPr/>
+          <a:lstStyle/>
+          <a:p>
+            <a:endParaRPr lang="en-MT"/>
+          </a:p>
+        </p:txBody>
+      </p:sp>
+      <p:pic>
+        <p:nvPicPr>
+          <p:cNvPr id="21" name="Image 2" descr="preencoded.png"/>
+          <p:cNvPicPr>
+            <a:picLocks noChangeAspect="1"/>
+          </p:cNvPicPr>
+          <p:nvPr/>
+        </p:nvPicPr>
+        <p:blipFill>
+          <a:blip r:embed="rId5"/>
+          <a:stretch>
+            <a:fillRect/>
+          </a:stretch>
+        </p:blipFill>
+        <p:spPr>
+          <a:xfrm>
+            <a:off x="6364818" y="1600199"/>
+            <a:ext cx="411480" cy="411480"/>
+          </a:xfrm>
+          <a:prstGeom prst="rect">
+            <a:avLst/>
+          </a:prstGeom>
+        </p:spPr>
+      </p:pic>
+      <p:sp>
+        <p:nvSpPr>
+          <p:cNvPr id="22" name="Text 17"/>
+          <p:cNvSpPr/>
+          <p:nvPr/>
+        </p:nvSpPr>
+        <p:spPr>
+          <a:xfrm>
+            <a:off x="6812280" y="1554480"/>
+            <a:ext cx="2103120" cy="384048"/>
+          </a:xfrm>
+          <a:prstGeom prst="rect">
+            <a:avLst/>
+          </a:prstGeom>
+          <a:noFill/>
+          <a:ln/>
+        </p:spPr>
+        <p:txBody>
+          <a:bodyPr wrap="square" rtlCol="0" anchor="ctr"/>
+          <a:lstStyle/>
+          <a:p>
+            <a:pPr marL="0" indent="0">
+              <a:buNone/>
+            </a:pPr>
+            <a:r>
+              <a:rPr lang="en-US" sz="1300" b="1" dirty="0">
+                <a:solidFill>
+                  <a:srgbClr val="FFFFFF"/>
+                </a:solidFill>
+                <a:latin typeface="Calibri" pitchFamily="34" charset="0"/>
+                <a:ea typeface="Calibri" pitchFamily="34" charset="-122"/>
+                <a:cs typeface="Calibri" pitchFamily="34" charset="-120"/>
+              </a:rPr>
+              <a:t>Google Photos (MobileNet)</a:t>
+            </a:r>
+            <a:endParaRPr lang="en-US" sz="1300" dirty="0"/>
+          </a:p>
+        </p:txBody>
+      </p:sp>
+      <p:sp>
+        <p:nvSpPr>
+          <p:cNvPr id="23" name="Text 18"/>
+          <p:cNvSpPr/>
+          <p:nvPr/>
+        </p:nvSpPr>
+        <p:spPr>
+          <a:xfrm>
+            <a:off x="6812280" y="1847088"/>
+            <a:ext cx="2103120" cy="228600"/>
+          </a:xfrm>
+          <a:prstGeom prst="rect">
+            <a:avLst/>
+          </a:prstGeom>
+          <a:noFill/>
+          <a:ln/>
+        </p:spPr>
+        <p:txBody>
+          <a:bodyPr wrap="square" rtlCol="0" anchor="ctr"/>
+          <a:lstStyle/>
+          <a:p>
+            <a:pPr marL="0" indent="0">
+              <a:buNone/>
+            </a:pPr>
+            <a:r>
+              <a:rPr lang="en-US" sz="1000" i="1" dirty="0">
+                <a:solidFill>
+                  <a:srgbClr val="F5A623"/>
+                </a:solidFill>
+                <a:latin typeface="Calibri" pitchFamily="34" charset="0"/>
+                <a:ea typeface="Calibri" pitchFamily="34" charset="-122"/>
+                <a:cs typeface="Calibri" pitchFamily="34" charset="-120"/>
+              </a:rPr>
+              <a:t>Depthwise Separable</a:t>
+            </a:r>
+            <a:endParaRPr lang="en-US" sz="1000" dirty="0"/>
+          </a:p>
+        </p:txBody>
+      </p:sp>
+      <p:sp>
+        <p:nvSpPr>
+          <p:cNvPr id="24" name="Shape 19"/>
+          <p:cNvSpPr/>
+          <p:nvPr/>
+        </p:nvSpPr>
+        <p:spPr>
+          <a:xfrm>
+            <a:off x="6355079" y="2148839"/>
+            <a:ext cx="2423161" cy="45719"/>
+          </a:xfrm>
+          <a:prstGeom prst="rect">
+            <a:avLst/>
+          </a:prstGeom>
+          <a:solidFill>
+            <a:srgbClr val="F5A623"/>
+          </a:solidFill>
+          <a:ln/>
+        </p:spPr>
+        <p:txBody>
+          <a:bodyPr/>
+          <a:lstStyle/>
+          <a:p>
+            <a:endParaRPr lang="en-MT"/>
+          </a:p>
+        </p:txBody>
+      </p:sp>
+      <p:sp>
+        <p:nvSpPr>
+          <p:cNvPr id="25" name="Text 20"/>
+          <p:cNvSpPr/>
+          <p:nvPr/>
+        </p:nvSpPr>
+        <p:spPr>
+          <a:xfrm>
+            <a:off x="6355080" y="2240280"/>
+            <a:ext cx="2377440" cy="2514600"/>
+          </a:xfrm>
+          <a:prstGeom prst="rect">
+            <a:avLst/>
+          </a:prstGeom>
+          <a:noFill/>
+          <a:ln/>
+        </p:spPr>
+        <p:txBody>
+          <a:bodyPr wrap="square" rtlCol="0" anchor="t"/>
+          <a:lstStyle/>
+          <a:p>
+            <a:r>
+              <a:rPr lang="en-US" sz="1100" dirty="0" err="1">
+                <a:solidFill>
+                  <a:srgbClr val="E8F4F8"/>
+                </a:solidFill>
+                <a:latin typeface="Calibri" pitchFamily="34" charset="0"/>
+                <a:ea typeface="Calibri" pitchFamily="34" charset="-122"/>
+                <a:cs typeface="Calibri" pitchFamily="34" charset="-120"/>
+              </a:rPr>
+              <a:t>MobileNets</a:t>
+            </a:r>
+            <a:r>
+              <a:rPr lang="en-US" sz="1100" dirty="0">
+                <a:solidFill>
+                  <a:srgbClr val="E8F4F8"/>
+                </a:solidFill>
+                <a:latin typeface="Calibri" pitchFamily="34" charset="0"/>
+                <a:ea typeface="Calibri" pitchFamily="34" charset="-122"/>
+                <a:cs typeface="Calibri" pitchFamily="34" charset="-120"/>
+              </a:rPr>
+              <a:t> use a smaller version of a standard CNN, but by using </a:t>
+            </a:r>
+            <a:r>
+              <a:rPr lang="en-US" sz="1100" dirty="0" err="1">
+                <a:solidFill>
+                  <a:srgbClr val="E8F4F8"/>
+                </a:solidFill>
+                <a:latin typeface="Calibri" pitchFamily="34" charset="0"/>
+                <a:ea typeface="Calibri" pitchFamily="34" charset="-122"/>
+                <a:cs typeface="Calibri" pitchFamily="34" charset="-120"/>
+              </a:rPr>
+              <a:t>depthwise</a:t>
+            </a:r>
+            <a:r>
+              <a:rPr lang="en-US" sz="1100" dirty="0">
+                <a:solidFill>
+                  <a:srgbClr val="E8F4F8"/>
+                </a:solidFill>
+                <a:latin typeface="Calibri" pitchFamily="34" charset="0"/>
+                <a:ea typeface="Calibri" pitchFamily="34" charset="-122"/>
+                <a:cs typeface="Calibri" pitchFamily="34" charset="-120"/>
+              </a:rPr>
+              <a:t> separable convolution — separating spatial filtering from channel mixing. The result: 8× fewer calculations and real-time classification of 1B+ photos daily without draining battery.</a:t>
+            </a:r>
+            <a:endParaRPr lang="en-US" sz="1100" dirty="0"/>
+          </a:p>
+        </p:txBody>
+      </p:sp>
+    </p:spTree>
+  </p:cSld>
+  <p:clrMapOvr>
+    <a:masterClrMapping/>
+  </p:clrMapOvr>
+</p:sld>
+</file>
+
+<file path=ppt/slides/slide11.xml><?xml version="1.0" encoding="utf-8"?>
+<p:sld xmlns:a="http://schemas.openxmlformats.org/drawingml/2006/main" xmlns:r="http://schemas.openxmlformats.org/officeDocument/2006/relationships" xmlns:p="http://schemas.openxmlformats.org/presentationml/2006/main">
   <p:cSld name="Slide 10">
     <p:bg>
       <p:bgPr>
@@ -2912,7 +3897,7 @@
 </p:sld>
 </file>
 
-<file path=ppt/slides/slide11.xml><?xml version="1.0" encoding="utf-8"?>
+<file path=ppt/slides/slide12.xml><?xml version="1.0" encoding="utf-8"?>
 <p:sld xmlns:a="http://schemas.openxmlformats.org/drawingml/2006/main" xmlns:r="http://schemas.openxmlformats.org/officeDocument/2006/relationships" xmlns:p="http://schemas.openxmlformats.org/presentationml/2006/main">
   <p:cSld name="Slide 11">
     <p:bg>
@@ -3740,7 +4725,7 @@
 </p:sld>
 </file>
 
-<file path=ppt/slides/slide12.xml><?xml version="1.0" encoding="utf-8"?>
+<file path=ppt/slides/slide13.xml><?xml version="1.0" encoding="utf-8"?>
 <p:sld xmlns:a="http://schemas.openxmlformats.org/drawingml/2006/main" xmlns:r="http://schemas.openxmlformats.org/officeDocument/2006/relationships" xmlns:p="http://schemas.openxmlformats.org/presentationml/2006/main">
   <p:cSld name="Slide 13">
     <p:bg>
@@ -4707,7 +5692,7 @@
 </p:sld>
 </file>
 
-<file path=ppt/slides/slide13.xml><?xml version="1.0" encoding="utf-8"?>
+<file path=ppt/slides/slide14.xml><?xml version="1.0" encoding="utf-8"?>
 <p:sld xmlns:a="http://schemas.openxmlformats.org/drawingml/2006/main" xmlns:r="http://schemas.openxmlformats.org/officeDocument/2006/relationships" xmlns:p="http://schemas.openxmlformats.org/presentationml/2006/main">
   <p:cSld name="Slide 14">
     <p:bg>
@@ -12945,6 +13930,593 @@
 
 <file path=ppt/slides/slide6.xml><?xml version="1.0" encoding="utf-8"?>
 <p:sld xmlns:a="http://schemas.openxmlformats.org/drawingml/2006/main" xmlns:r="http://schemas.openxmlformats.org/officeDocument/2006/relationships" xmlns:p="http://schemas.openxmlformats.org/presentationml/2006/main">
+  <p:cSld>
+    <p:bg>
+      <p:bgPr>
+        <a:solidFill>
+          <a:srgbClr val="0A1628"/>
+        </a:solidFill>
+        <a:effectLst/>
+      </p:bgPr>
+    </p:bg>
+    <p:spTree>
+      <p:nvGrpSpPr>
+        <p:cNvPr id="1" name="">
+          <a:extLst>
+            <a:ext uri="{FF2B5EF4-FFF2-40B4-BE49-F238E27FC236}">
+              <a16:creationId xmlns:a16="http://schemas.microsoft.com/office/drawing/2014/main" id="{5BAF1B4D-15B0-7678-5815-AB532A8F9CBF}"/>
+            </a:ext>
+          </a:extLst>
+        </p:cNvPr>
+        <p:cNvGrpSpPr/>
+        <p:nvPr/>
+      </p:nvGrpSpPr>
+      <p:grpSpPr>
+        <a:xfrm>
+          <a:off x="0" y="0"/>
+          <a:ext cx="0" cy="0"/>
+          <a:chOff x="0" y="0"/>
+          <a:chExt cx="0" cy="0"/>
+        </a:xfrm>
+      </p:grpSpPr>
+      <p:sp>
+        <p:nvSpPr>
+          <p:cNvPr id="51" name="Shape 3">
+            <a:extLst>
+              <a:ext uri="{FF2B5EF4-FFF2-40B4-BE49-F238E27FC236}">
+                <a16:creationId xmlns:a16="http://schemas.microsoft.com/office/drawing/2014/main" id="{0AAC52D1-755B-49EB-D362-6BE29870A2A6}"/>
+              </a:ext>
+            </a:extLst>
+          </p:cNvPr>
+          <p:cNvSpPr/>
+          <p:nvPr/>
+        </p:nvSpPr>
+        <p:spPr>
+          <a:xfrm>
+            <a:off x="168812" y="992192"/>
+            <a:ext cx="8700868" cy="3311584"/>
+          </a:xfrm>
+          <a:prstGeom prst="rect">
+            <a:avLst/>
+          </a:prstGeom>
+          <a:solidFill>
+            <a:srgbClr val="122040"/>
+          </a:solidFill>
+          <a:ln/>
+          <a:effectLst>
+            <a:outerShdw blurRad="101600" dist="38100" dir="8100000" algn="bl" rotWithShape="0">
+              <a:srgbClr val="000000">
+                <a:alpha val="18000"/>
+              </a:srgbClr>
+            </a:outerShdw>
+          </a:effectLst>
+        </p:spPr>
+        <p:txBody>
+          <a:bodyPr/>
+          <a:lstStyle/>
+          <a:p>
+            <a:endParaRPr lang="en-MT"/>
+          </a:p>
+        </p:txBody>
+      </p:sp>
+      <p:sp>
+        <p:nvSpPr>
+          <p:cNvPr id="2" name="Text 0">
+            <a:extLst>
+              <a:ext uri="{FF2B5EF4-FFF2-40B4-BE49-F238E27FC236}">
+                <a16:creationId xmlns:a16="http://schemas.microsoft.com/office/drawing/2014/main" id="{E63E8ADE-4BDD-EEF0-B508-787DFB205272}"/>
+              </a:ext>
+            </a:extLst>
+          </p:cNvPr>
+          <p:cNvSpPr/>
+          <p:nvPr/>
+        </p:nvSpPr>
+        <p:spPr>
+          <a:xfrm>
+            <a:off x="365760" y="137160"/>
+            <a:ext cx="8412480" cy="594360"/>
+          </a:xfrm>
+          <a:prstGeom prst="rect">
+            <a:avLst/>
+          </a:prstGeom>
+          <a:noFill/>
+          <a:ln/>
+        </p:spPr>
+        <p:txBody>
+          <a:bodyPr wrap="square" rtlCol="0" anchor="ctr"/>
+          <a:lstStyle/>
+          <a:p>
+            <a:pPr marL="0" indent="0">
+              <a:buNone/>
+            </a:pPr>
+            <a:r>
+              <a:rPr lang="en-US" sz="2800" b="1" dirty="0">
+                <a:solidFill>
+                  <a:srgbClr val="FFFFFF"/>
+                </a:solidFill>
+                <a:latin typeface="Calibri" pitchFamily="34" charset="0"/>
+                <a:ea typeface="Calibri" pitchFamily="34" charset="-122"/>
+                <a:cs typeface="Calibri" pitchFamily="34" charset="-120"/>
+              </a:rPr>
+              <a:t>Kernels In Action</a:t>
+            </a:r>
+            <a:endParaRPr lang="en-US" sz="2800" dirty="0"/>
+          </a:p>
+        </p:txBody>
+      </p:sp>
+      <p:sp>
+        <p:nvSpPr>
+          <p:cNvPr id="3" name="Shape 1">
+            <a:extLst>
+              <a:ext uri="{FF2B5EF4-FFF2-40B4-BE49-F238E27FC236}">
+                <a16:creationId xmlns:a16="http://schemas.microsoft.com/office/drawing/2014/main" id="{CFF2ABB8-139B-E8D6-8358-F3BB5626D7BA}"/>
+              </a:ext>
+            </a:extLst>
+          </p:cNvPr>
+          <p:cNvSpPr/>
+          <p:nvPr/>
+        </p:nvSpPr>
+        <p:spPr>
+          <a:xfrm>
+            <a:off x="365760" y="758952"/>
+            <a:ext cx="8412480" cy="36576"/>
+          </a:xfrm>
+          <a:prstGeom prst="rect">
+            <a:avLst/>
+          </a:prstGeom>
+          <a:solidFill>
+            <a:srgbClr val="00C2CB"/>
+          </a:solidFill>
+          <a:ln/>
+        </p:spPr>
+        <p:txBody>
+          <a:bodyPr/>
+          <a:lstStyle/>
+          <a:p>
+            <a:endParaRPr lang="en-MT"/>
+          </a:p>
+        </p:txBody>
+      </p:sp>
+      <p:pic>
+        <p:nvPicPr>
+          <p:cNvPr id="31" name="Picture 30">
+            <a:extLst>
+              <a:ext uri="{FF2B5EF4-FFF2-40B4-BE49-F238E27FC236}">
+                <a16:creationId xmlns:a16="http://schemas.microsoft.com/office/drawing/2014/main" id="{1B2935CB-A5A1-14AB-1AD6-3F918D66D3CC}"/>
+              </a:ext>
+            </a:extLst>
+          </p:cNvPr>
+          <p:cNvPicPr>
+            <a:picLocks noChangeAspect="1"/>
+          </p:cNvPicPr>
+          <p:nvPr/>
+        </p:nvPicPr>
+        <p:blipFill>
+          <a:blip r:embed="rId3"/>
+          <a:stretch>
+            <a:fillRect/>
+          </a:stretch>
+        </p:blipFill>
+        <p:spPr>
+          <a:xfrm>
+            <a:off x="365760" y="1162575"/>
+            <a:ext cx="1807639" cy="1807639"/>
+          </a:xfrm>
+          <a:prstGeom prst="rect">
+            <a:avLst/>
+          </a:prstGeom>
+          <a:ln>
+            <a:solidFill>
+              <a:schemeClr val="bg1"/>
+            </a:solidFill>
+          </a:ln>
+        </p:spPr>
+      </p:pic>
+      <p:pic>
+        <p:nvPicPr>
+          <p:cNvPr id="39" name="Picture 38">
+            <a:extLst>
+              <a:ext uri="{FF2B5EF4-FFF2-40B4-BE49-F238E27FC236}">
+                <a16:creationId xmlns:a16="http://schemas.microsoft.com/office/drawing/2014/main" id="{3C842F63-E55E-6F43-1C9B-B5097C4E665B}"/>
+              </a:ext>
+            </a:extLst>
+          </p:cNvPr>
+          <p:cNvPicPr>
+            <a:picLocks noChangeAspect="1"/>
+          </p:cNvPicPr>
+          <p:nvPr/>
+        </p:nvPicPr>
+        <p:blipFill>
+          <a:blip r:embed="rId4"/>
+          <a:stretch>
+            <a:fillRect/>
+          </a:stretch>
+        </p:blipFill>
+        <p:spPr>
+          <a:xfrm>
+            <a:off x="4705953" y="1163014"/>
+            <a:ext cx="1807200" cy="1807200"/>
+          </a:xfrm>
+          <a:prstGeom prst="rect">
+            <a:avLst/>
+          </a:prstGeom>
+          <a:ln>
+            <a:solidFill>
+              <a:schemeClr val="bg1"/>
+            </a:solidFill>
+          </a:ln>
+        </p:spPr>
+      </p:pic>
+      <p:pic>
+        <p:nvPicPr>
+          <p:cNvPr id="41" name="Picture 40">
+            <a:extLst>
+              <a:ext uri="{FF2B5EF4-FFF2-40B4-BE49-F238E27FC236}">
+                <a16:creationId xmlns:a16="http://schemas.microsoft.com/office/drawing/2014/main" id="{AEEF5F34-B17E-6D48-4226-BB96347D29E9}"/>
+              </a:ext>
+            </a:extLst>
+          </p:cNvPr>
+          <p:cNvPicPr>
+            <a:picLocks noChangeAspect="1"/>
+          </p:cNvPicPr>
+          <p:nvPr/>
+        </p:nvPicPr>
+        <p:blipFill>
+          <a:blip r:embed="rId5"/>
+          <a:stretch>
+            <a:fillRect/>
+          </a:stretch>
+        </p:blipFill>
+        <p:spPr>
+          <a:xfrm>
+            <a:off x="6875830" y="1163014"/>
+            <a:ext cx="1807200" cy="1807200"/>
+          </a:xfrm>
+          <a:prstGeom prst="rect">
+            <a:avLst/>
+          </a:prstGeom>
+          <a:ln>
+            <a:solidFill>
+              <a:schemeClr val="bg1"/>
+            </a:solidFill>
+          </a:ln>
+        </p:spPr>
+      </p:pic>
+      <p:pic>
+        <p:nvPicPr>
+          <p:cNvPr id="45" name="Picture 44">
+            <a:extLst>
+              <a:ext uri="{FF2B5EF4-FFF2-40B4-BE49-F238E27FC236}">
+                <a16:creationId xmlns:a16="http://schemas.microsoft.com/office/drawing/2014/main" id="{FF3B0CE1-B2C8-44C8-B302-168D5EB6DC35}"/>
+              </a:ext>
+            </a:extLst>
+          </p:cNvPr>
+          <p:cNvPicPr>
+            <a:picLocks noChangeAspect="1"/>
+          </p:cNvPicPr>
+          <p:nvPr/>
+        </p:nvPicPr>
+        <p:blipFill>
+          <a:blip r:embed="rId6"/>
+          <a:stretch>
+            <a:fillRect/>
+          </a:stretch>
+        </p:blipFill>
+        <p:spPr>
+          <a:xfrm>
+            <a:off x="2536076" y="1162575"/>
+            <a:ext cx="1807200" cy="1807200"/>
+          </a:xfrm>
+          <a:prstGeom prst="rect">
+            <a:avLst/>
+          </a:prstGeom>
+          <a:ln>
+            <a:solidFill>
+              <a:schemeClr val="bg1"/>
+            </a:solidFill>
+          </a:ln>
+        </p:spPr>
+      </p:pic>
+      <p:sp>
+        <p:nvSpPr>
+          <p:cNvPr id="53" name="Shape 3">
+            <a:extLst>
+              <a:ext uri="{FF2B5EF4-FFF2-40B4-BE49-F238E27FC236}">
+                <a16:creationId xmlns:a16="http://schemas.microsoft.com/office/drawing/2014/main" id="{B982BED7-BFB8-2CD9-E26E-628A93F668D9}"/>
+              </a:ext>
+            </a:extLst>
+          </p:cNvPr>
+          <p:cNvSpPr/>
+          <p:nvPr/>
+        </p:nvSpPr>
+        <p:spPr>
+          <a:xfrm>
+            <a:off x="365760" y="3294873"/>
+            <a:ext cx="1807639" cy="435289"/>
+          </a:xfrm>
+          <a:prstGeom prst="rect">
+            <a:avLst/>
+          </a:prstGeom>
+          <a:solidFill>
+            <a:srgbClr val="C00000"/>
+          </a:solidFill>
+          <a:ln/>
+          <a:effectLst>
+            <a:outerShdw blurRad="101600" dist="38100" dir="8100000" algn="bl" rotWithShape="0">
+              <a:srgbClr val="000000">
+                <a:alpha val="18000"/>
+              </a:srgbClr>
+            </a:outerShdw>
+          </a:effectLst>
+        </p:spPr>
+        <p:txBody>
+          <a:bodyPr anchor="ctr"/>
+          <a:lstStyle/>
+          <a:p>
+            <a:pPr algn="ctr"/>
+            <a:r>
+              <a:rPr lang="en-GB" sz="1100" b="1" dirty="0">
+                <a:solidFill>
+                  <a:srgbClr val="E8F4F8"/>
+                </a:solidFill>
+                <a:latin typeface="Calibri" pitchFamily="34" charset="0"/>
+                <a:ea typeface="Calibri" pitchFamily="34" charset="-122"/>
+                <a:cs typeface="Calibri" pitchFamily="34" charset="-120"/>
+              </a:rPr>
+              <a:t>Original</a:t>
+            </a:r>
+            <a:endParaRPr lang="en-MT" sz="1100" b="1" dirty="0">
+              <a:solidFill>
+                <a:srgbClr val="E8F4F8"/>
+              </a:solidFill>
+              <a:latin typeface="Calibri" pitchFamily="34" charset="0"/>
+              <a:ea typeface="Calibri" pitchFamily="34" charset="-122"/>
+              <a:cs typeface="Calibri" pitchFamily="34" charset="-120"/>
+            </a:endParaRPr>
+          </a:p>
+        </p:txBody>
+      </p:sp>
+      <p:sp>
+        <p:nvSpPr>
+          <p:cNvPr id="56" name="Shape 3">
+            <a:extLst>
+              <a:ext uri="{FF2B5EF4-FFF2-40B4-BE49-F238E27FC236}">
+                <a16:creationId xmlns:a16="http://schemas.microsoft.com/office/drawing/2014/main" id="{8A2381C5-8F2F-860C-0533-E06C31D86A15}"/>
+              </a:ext>
+            </a:extLst>
+          </p:cNvPr>
+          <p:cNvSpPr/>
+          <p:nvPr/>
+        </p:nvSpPr>
+        <p:spPr>
+          <a:xfrm>
+            <a:off x="2535637" y="3294873"/>
+            <a:ext cx="1807639" cy="435289"/>
+          </a:xfrm>
+          <a:prstGeom prst="rect">
+            <a:avLst/>
+          </a:prstGeom>
+          <a:solidFill>
+            <a:srgbClr val="00B050"/>
+          </a:solidFill>
+          <a:ln/>
+          <a:effectLst>
+            <a:outerShdw blurRad="101600" dist="38100" dir="8100000" algn="bl" rotWithShape="0">
+              <a:srgbClr val="000000">
+                <a:alpha val="18000"/>
+              </a:srgbClr>
+            </a:outerShdw>
+          </a:effectLst>
+        </p:spPr>
+        <p:txBody>
+          <a:bodyPr anchor="ctr"/>
+          <a:lstStyle/>
+          <a:p>
+            <a:pPr algn="ctr"/>
+            <a:r>
+              <a:rPr lang="en-GB" sz="1100" b="1" dirty="0">
+                <a:solidFill>
+                  <a:srgbClr val="E8F4F8"/>
+                </a:solidFill>
+                <a:latin typeface="Calibri" pitchFamily="34" charset="0"/>
+                <a:ea typeface="Calibri" pitchFamily="34" charset="-122"/>
+                <a:cs typeface="Calibri" pitchFamily="34" charset="-120"/>
+              </a:rPr>
+              <a:t>Gaussian σ=5 — noise removed, edges softened</a:t>
+            </a:r>
+            <a:endParaRPr lang="en-US" sz="1100" b="1" dirty="0"/>
+          </a:p>
+        </p:txBody>
+      </p:sp>
+      <p:sp>
+        <p:nvSpPr>
+          <p:cNvPr id="57" name="Shape 3">
+            <a:extLst>
+              <a:ext uri="{FF2B5EF4-FFF2-40B4-BE49-F238E27FC236}">
+                <a16:creationId xmlns:a16="http://schemas.microsoft.com/office/drawing/2014/main" id="{B1519CDD-A1C1-C7E1-CF53-DF9C12CA75BD}"/>
+              </a:ext>
+            </a:extLst>
+          </p:cNvPr>
+          <p:cNvSpPr/>
+          <p:nvPr/>
+        </p:nvSpPr>
+        <p:spPr>
+          <a:xfrm>
+            <a:off x="4714957" y="3294873"/>
+            <a:ext cx="1807639" cy="435289"/>
+          </a:xfrm>
+          <a:prstGeom prst="rect">
+            <a:avLst/>
+          </a:prstGeom>
+          <a:solidFill>
+            <a:srgbClr val="0070C0"/>
+          </a:solidFill>
+          <a:ln/>
+          <a:effectLst>
+            <a:outerShdw blurRad="101600" dist="38100" dir="8100000" algn="bl" rotWithShape="0">
+              <a:srgbClr val="000000">
+                <a:alpha val="18000"/>
+              </a:srgbClr>
+            </a:outerShdw>
+          </a:effectLst>
+        </p:spPr>
+        <p:txBody>
+          <a:bodyPr anchor="ctr"/>
+          <a:lstStyle/>
+          <a:p>
+            <a:pPr algn="ctr"/>
+            <a:r>
+              <a:rPr lang="en-GB" sz="1100" b="1" dirty="0">
+                <a:solidFill>
+                  <a:srgbClr val="E8F4F8"/>
+                </a:solidFill>
+                <a:latin typeface="Calibri" pitchFamily="34" charset="0"/>
+                <a:ea typeface="Calibri" pitchFamily="34" charset="-122"/>
+                <a:cs typeface="Calibri" pitchFamily="34" charset="-120"/>
+              </a:rPr>
+              <a:t>Sobel Combined — all edges detected</a:t>
+            </a:r>
+            <a:endParaRPr lang="en-US" sz="1100" b="1" dirty="0">
+              <a:solidFill>
+                <a:srgbClr val="E8F4F8"/>
+              </a:solidFill>
+              <a:latin typeface="Calibri" pitchFamily="34" charset="0"/>
+              <a:ea typeface="Calibri" pitchFamily="34" charset="-122"/>
+              <a:cs typeface="Calibri" pitchFamily="34" charset="-120"/>
+            </a:endParaRPr>
+          </a:p>
+        </p:txBody>
+      </p:sp>
+      <p:sp>
+        <p:nvSpPr>
+          <p:cNvPr id="58" name="Shape 3">
+            <a:extLst>
+              <a:ext uri="{FF2B5EF4-FFF2-40B4-BE49-F238E27FC236}">
+                <a16:creationId xmlns:a16="http://schemas.microsoft.com/office/drawing/2014/main" id="{D74EC35B-5EB1-D16B-C572-339B6AB48A04}"/>
+              </a:ext>
+            </a:extLst>
+          </p:cNvPr>
+          <p:cNvSpPr/>
+          <p:nvPr/>
+        </p:nvSpPr>
+        <p:spPr>
+          <a:xfrm>
+            <a:off x="6894277" y="3294873"/>
+            <a:ext cx="1807639" cy="435289"/>
+          </a:xfrm>
+          <a:prstGeom prst="rect">
+            <a:avLst/>
+          </a:prstGeom>
+          <a:solidFill>
+            <a:srgbClr val="7030A0"/>
+          </a:solidFill>
+          <a:ln/>
+          <a:effectLst>
+            <a:outerShdw blurRad="101600" dist="38100" dir="8100000" algn="bl" rotWithShape="0">
+              <a:srgbClr val="000000">
+                <a:alpha val="18000"/>
+              </a:srgbClr>
+            </a:outerShdw>
+          </a:effectLst>
+        </p:spPr>
+        <p:txBody>
+          <a:bodyPr anchor="ctr"/>
+          <a:lstStyle/>
+          <a:p>
+            <a:pPr algn="ctr"/>
+            <a:r>
+              <a:rPr lang="en-GB" sz="1100" b="1" dirty="0">
+                <a:solidFill>
+                  <a:srgbClr val="E8F4F8"/>
+                </a:solidFill>
+                <a:latin typeface="Calibri" pitchFamily="34" charset="0"/>
+                <a:ea typeface="Calibri" pitchFamily="34" charset="-122"/>
+                <a:cs typeface="Calibri" pitchFamily="34" charset="-120"/>
+              </a:rPr>
+              <a:t>Laplacian — fine edge sensitivity</a:t>
+            </a:r>
+            <a:endParaRPr lang="en-MT" sz="1100" b="1" dirty="0">
+              <a:solidFill>
+                <a:srgbClr val="E8F4F8"/>
+              </a:solidFill>
+              <a:latin typeface="Calibri" pitchFamily="34" charset="0"/>
+              <a:ea typeface="Calibri" pitchFamily="34" charset="-122"/>
+              <a:cs typeface="Calibri" pitchFamily="34" charset="-120"/>
+            </a:endParaRPr>
+          </a:p>
+        </p:txBody>
+      </p:sp>
+      <p:sp>
+        <p:nvSpPr>
+          <p:cNvPr id="4" name="Text 7">
+            <a:extLst>
+              <a:ext uri="{FF2B5EF4-FFF2-40B4-BE49-F238E27FC236}">
+                <a16:creationId xmlns:a16="http://schemas.microsoft.com/office/drawing/2014/main" id="{290C1E16-0240-9DC8-BD42-0B86FA071714}"/>
+              </a:ext>
+            </a:extLst>
+          </p:cNvPr>
+          <p:cNvSpPr/>
+          <p:nvPr/>
+        </p:nvSpPr>
+        <p:spPr>
+          <a:xfrm>
+            <a:off x="1730326" y="4399835"/>
+            <a:ext cx="5577840" cy="457200"/>
+          </a:xfrm>
+          <a:prstGeom prst="rect">
+            <a:avLst/>
+          </a:prstGeom>
+          <a:solidFill>
+            <a:schemeClr val="tx2">
+              <a:lumMod val="75000"/>
+            </a:schemeClr>
+          </a:solidFill>
+          <a:ln/>
+          <a:effectLst>
+            <a:innerShdw blurRad="63500" dist="50800" dir="16200000">
+              <a:prstClr val="black">
+                <a:alpha val="50000"/>
+              </a:prstClr>
+            </a:innerShdw>
+          </a:effectLst>
+        </p:spPr>
+        <p:txBody>
+          <a:bodyPr wrap="square" rtlCol="0" anchor="ctr"/>
+          <a:lstStyle/>
+          <a:p>
+            <a:pPr marL="0" indent="0" algn="ctr">
+              <a:buNone/>
+            </a:pPr>
+            <a:r>
+              <a:rPr lang="en-US" sz="1350" i="1" dirty="0">
+                <a:solidFill>
+                  <a:srgbClr val="E8F4F8"/>
+                </a:solidFill>
+                <a:latin typeface="Calibri" pitchFamily="34" charset="0"/>
+                <a:ea typeface="Calibri" pitchFamily="34" charset="-122"/>
+                <a:cs typeface="Calibri" pitchFamily="34" charset="-120"/>
+              </a:rPr>
+              <a:t>Screenshots taken from Simulator</a:t>
+            </a:r>
+            <a:endParaRPr lang="en-US" sz="1350" i="1" dirty="0"/>
+          </a:p>
+        </p:txBody>
+      </p:sp>
+    </p:spTree>
+    <p:extLst>
+      <p:ext uri="{BB962C8B-B14F-4D97-AF65-F5344CB8AC3E}">
+        <p14:creationId xmlns:p14="http://schemas.microsoft.com/office/powerpoint/2010/main" val="944847597"/>
+      </p:ext>
+    </p:extLst>
+  </p:cSld>
+  <p:clrMapOvr>
+    <a:masterClrMapping/>
+  </p:clrMapOvr>
+</p:sld>
+</file>
+
+<file path=ppt/slides/slide7.xml><?xml version="1.0" encoding="utf-8"?>
+<p:sld xmlns:a="http://schemas.openxmlformats.org/drawingml/2006/main" xmlns:r="http://schemas.openxmlformats.org/officeDocument/2006/relationships" xmlns:p="http://schemas.openxmlformats.org/presentationml/2006/main">
   <p:cSld name="Slide 6">
     <p:bg>
       <p:bgPr>
@@ -14257,7 +15829,7 @@
 </p:sld>
 </file>
 
-<file path=ppt/slides/slide7.xml><?xml version="1.0" encoding="utf-8"?>
+<file path=ppt/slides/slide8.xml><?xml version="1.0" encoding="utf-8"?>
 <p:sld xmlns:a="http://schemas.openxmlformats.org/drawingml/2006/main" xmlns:r="http://schemas.openxmlformats.org/officeDocument/2006/relationships" xmlns:p="http://schemas.openxmlformats.org/presentationml/2006/main">
   <p:cSld name="Slide 7">
     <p:bg>
@@ -15439,7 +17011,7 @@
 </p:sld>
 </file>
 
-<file path=ppt/slides/slide8.xml><?xml version="1.0" encoding="utf-8"?>
+<file path=ppt/slides/slide9.xml><?xml version="1.0" encoding="utf-8"?>
 <p:sld xmlns:a="http://schemas.openxmlformats.org/drawingml/2006/main" xmlns:r="http://schemas.openxmlformats.org/officeDocument/2006/relationships" xmlns:p="http://schemas.openxmlformats.org/presentationml/2006/main">
   <p:cSld name="Slide 8">
     <p:bg>
@@ -16182,882 +17754,6 @@
               <a:t>  (~8× faster)</a:t>
             </a:r>
             <a:endParaRPr lang="en-US" sz="1200" dirty="0"/>
-          </a:p>
-        </p:txBody>
-      </p:sp>
-    </p:spTree>
-  </p:cSld>
-  <p:clrMapOvr>
-    <a:masterClrMapping/>
-  </p:clrMapOvr>
-</p:sld>
-</file>
-
-<file path=ppt/slides/slide9.xml><?xml version="1.0" encoding="utf-8"?>
-<p:sld xmlns:a="http://schemas.openxmlformats.org/drawingml/2006/main" xmlns:r="http://schemas.openxmlformats.org/officeDocument/2006/relationships" xmlns:p="http://schemas.openxmlformats.org/presentationml/2006/main">
-  <p:cSld name="Slide 9">
-    <p:bg>
-      <p:bgPr>
-        <a:solidFill>
-          <a:srgbClr val="0A1628"/>
-        </a:solidFill>
-        <a:effectLst/>
-      </p:bgPr>
-    </p:bg>
-    <p:spTree>
-      <p:nvGrpSpPr>
-        <p:cNvPr id="1" name=""/>
-        <p:cNvGrpSpPr/>
-        <p:nvPr/>
-      </p:nvGrpSpPr>
-      <p:grpSpPr>
-        <a:xfrm>
-          <a:off x="0" y="0"/>
-          <a:ext cx="0" cy="0"/>
-          <a:chOff x="0" y="0"/>
-          <a:chExt cx="0" cy="0"/>
-        </a:xfrm>
-      </p:grpSpPr>
-      <p:sp>
-        <p:nvSpPr>
-          <p:cNvPr id="2" name="Text 0"/>
-          <p:cNvSpPr/>
-          <p:nvPr/>
-        </p:nvSpPr>
-        <p:spPr>
-          <a:xfrm>
-            <a:off x="365760" y="137160"/>
-            <a:ext cx="4114800" cy="548640"/>
-          </a:xfrm>
-          <a:prstGeom prst="rect">
-            <a:avLst/>
-          </a:prstGeom>
-          <a:noFill/>
-          <a:ln/>
-        </p:spPr>
-        <p:txBody>
-          <a:bodyPr wrap="square" rtlCol="0" anchor="ctr"/>
-          <a:lstStyle/>
-          <a:p>
-            <a:pPr marL="0" indent="0">
-              <a:buNone/>
-            </a:pPr>
-            <a:r>
-              <a:rPr lang="en-US" sz="1200" kern="0" spc="300" dirty="0">
-                <a:solidFill>
-                  <a:srgbClr val="00C2CB"/>
-                </a:solidFill>
-                <a:latin typeface="Calibri" pitchFamily="34" charset="0"/>
-                <a:ea typeface="Calibri" pitchFamily="34" charset="-122"/>
-                <a:cs typeface="Calibri" pitchFamily="34" charset="-120"/>
-              </a:rPr>
-              <a:t>Real-World Case Study</a:t>
-            </a:r>
-            <a:endParaRPr lang="en-US" sz="1200" dirty="0"/>
-          </a:p>
-        </p:txBody>
-      </p:sp>
-      <p:sp>
-        <p:nvSpPr>
-          <p:cNvPr id="3" name="Text 1"/>
-          <p:cNvSpPr/>
-          <p:nvPr/>
-        </p:nvSpPr>
-        <p:spPr>
-          <a:xfrm>
-            <a:off x="365760" y="502920"/>
-            <a:ext cx="8412480" cy="777240"/>
-          </a:xfrm>
-          <a:prstGeom prst="rect">
-            <a:avLst/>
-          </a:prstGeom>
-          <a:noFill/>
-          <a:ln/>
-        </p:spPr>
-        <p:txBody>
-          <a:bodyPr wrap="square" rtlCol="0" anchor="ctr"/>
-          <a:lstStyle/>
-          <a:p>
-            <a:pPr marL="0" indent="0">
-              <a:buNone/>
-            </a:pPr>
-            <a:r>
-              <a:rPr lang="en-US" sz="2200" b="1" dirty="0">
-                <a:solidFill>
-                  <a:srgbClr val="FFFFFF"/>
-                </a:solidFill>
-                <a:latin typeface="Calibri" pitchFamily="34" charset="0"/>
-                <a:ea typeface="Calibri" pitchFamily="34" charset="-122"/>
-                <a:cs typeface="Calibri" pitchFamily="34" charset="-120"/>
-              </a:rPr>
-              <a:t>Kernels in Action: Self-Driving Cars, Medical AI &amp; Mobile Vision</a:t>
-            </a:r>
-            <a:endParaRPr lang="en-US" sz="2200" dirty="0"/>
-          </a:p>
-        </p:txBody>
-      </p:sp>
-      <p:sp>
-        <p:nvSpPr>
-          <p:cNvPr id="4" name="Shape 2"/>
-          <p:cNvSpPr/>
-          <p:nvPr/>
-        </p:nvSpPr>
-        <p:spPr>
-          <a:xfrm>
-            <a:off x="274321" y="1227937"/>
-            <a:ext cx="8641079" cy="64193"/>
-          </a:xfrm>
-          <a:prstGeom prst="rect">
-            <a:avLst/>
-          </a:prstGeom>
-          <a:solidFill>
-            <a:srgbClr val="00C2CB"/>
-          </a:solidFill>
-          <a:ln/>
-        </p:spPr>
-        <p:txBody>
-          <a:bodyPr/>
-          <a:lstStyle/>
-          <a:p>
-            <a:endParaRPr lang="en-MT"/>
-          </a:p>
-        </p:txBody>
-      </p:sp>
-      <p:sp>
-        <p:nvSpPr>
-          <p:cNvPr id="5" name="Shape 3"/>
-          <p:cNvSpPr/>
-          <p:nvPr/>
-        </p:nvSpPr>
-        <p:spPr>
-          <a:xfrm>
-            <a:off x="274321" y="1417320"/>
-            <a:ext cx="2697480" cy="3474720"/>
-          </a:xfrm>
-          <a:prstGeom prst="rect">
-            <a:avLst/>
-          </a:prstGeom>
-          <a:solidFill>
-            <a:srgbClr val="122040"/>
-          </a:solidFill>
-          <a:ln/>
-          <a:effectLst>
-            <a:outerShdw blurRad="101600" dist="38100" dir="8100000" algn="bl" rotWithShape="0">
-              <a:srgbClr val="000000">
-                <a:alpha val="18000"/>
-              </a:srgbClr>
-            </a:outerShdw>
-          </a:effectLst>
-        </p:spPr>
-        <p:txBody>
-          <a:bodyPr/>
-          <a:lstStyle/>
-          <a:p>
-            <a:endParaRPr lang="en-MT"/>
-          </a:p>
-        </p:txBody>
-      </p:sp>
-      <p:grpSp>
-        <p:nvGrpSpPr>
-          <p:cNvPr id="27" name="Group 26">
-            <a:extLst>
-              <a:ext uri="{FF2B5EF4-FFF2-40B4-BE49-F238E27FC236}">
-                <a16:creationId xmlns:a16="http://schemas.microsoft.com/office/drawing/2014/main" id="{420B0913-8DEE-B7C5-9F84-C3E3E88E5A54}"/>
-              </a:ext>
-            </a:extLst>
-          </p:cNvPr>
-          <p:cNvGrpSpPr/>
-          <p:nvPr/>
-        </p:nvGrpSpPr>
-        <p:grpSpPr>
-          <a:xfrm>
-            <a:off x="274320" y="1417320"/>
-            <a:ext cx="2697480" cy="3337560"/>
-            <a:chOff x="274320" y="1417320"/>
-            <a:chExt cx="2697480" cy="3337560"/>
-          </a:xfrm>
-        </p:grpSpPr>
-        <p:sp>
-          <p:nvSpPr>
-            <p:cNvPr id="6" name="Shape 4"/>
-            <p:cNvSpPr/>
-            <p:nvPr/>
-          </p:nvSpPr>
-          <p:spPr>
-            <a:xfrm>
-              <a:off x="274320" y="1417320"/>
-              <a:ext cx="2697480" cy="82296"/>
-            </a:xfrm>
-            <a:prstGeom prst="rect">
-              <a:avLst/>
-            </a:prstGeom>
-            <a:solidFill>
-              <a:srgbClr val="E84545"/>
-            </a:solidFill>
-            <a:ln/>
-          </p:spPr>
-          <p:txBody>
-            <a:bodyPr/>
-            <a:lstStyle/>
-            <a:p>
-              <a:endParaRPr lang="en-MT"/>
-            </a:p>
-          </p:txBody>
-        </p:sp>
-        <p:pic>
-          <p:nvPicPr>
-            <p:cNvPr id="7" name="Image 0" descr="preencoded.png"/>
-            <p:cNvPicPr>
-              <a:picLocks noChangeAspect="1"/>
-            </p:cNvPicPr>
-            <p:nvPr/>
-          </p:nvPicPr>
-          <p:blipFill>
-            <a:blip r:embed="rId3"/>
-            <a:stretch>
-              <a:fillRect/>
-            </a:stretch>
-          </p:blipFill>
-          <p:spPr>
-            <a:xfrm>
-              <a:off x="428652" y="1628895"/>
-              <a:ext cx="411480" cy="411480"/>
-            </a:xfrm>
-            <a:prstGeom prst="rect">
-              <a:avLst/>
-            </a:prstGeom>
-          </p:spPr>
-        </p:pic>
-        <p:sp>
-          <p:nvSpPr>
-            <p:cNvPr id="8" name="Text 5"/>
-            <p:cNvSpPr/>
-            <p:nvPr/>
-          </p:nvSpPr>
-          <p:spPr>
-            <a:xfrm>
-              <a:off x="868680" y="1554480"/>
-              <a:ext cx="2103120" cy="274320"/>
-            </a:xfrm>
-            <a:prstGeom prst="rect">
-              <a:avLst/>
-            </a:prstGeom>
-            <a:noFill/>
-            <a:ln/>
-          </p:spPr>
-          <p:txBody>
-            <a:bodyPr wrap="square" rtlCol="0" anchor="ctr"/>
-            <a:lstStyle/>
-            <a:p>
-              <a:pPr marL="0" indent="0">
-                <a:buNone/>
-              </a:pPr>
-              <a:r>
-                <a:rPr lang="en-US" sz="1300" b="1" dirty="0">
-                  <a:solidFill>
-                    <a:srgbClr val="FFFFFF"/>
-                  </a:solidFill>
-                  <a:latin typeface="Calibri" pitchFamily="34" charset="0"/>
-                  <a:ea typeface="Calibri" pitchFamily="34" charset="-122"/>
-                  <a:cs typeface="Calibri" pitchFamily="34" charset="-120"/>
-                </a:rPr>
-                <a:t>Tesla Autopilot</a:t>
-              </a:r>
-              <a:endParaRPr lang="en-US" sz="1300" dirty="0"/>
-            </a:p>
-          </p:txBody>
-        </p:sp>
-        <p:sp>
-          <p:nvSpPr>
-            <p:cNvPr id="9" name="Text 6"/>
-            <p:cNvSpPr/>
-            <p:nvPr/>
-          </p:nvSpPr>
-          <p:spPr>
-            <a:xfrm>
-              <a:off x="868680" y="1847088"/>
-              <a:ext cx="2103120" cy="228600"/>
-            </a:xfrm>
-            <a:prstGeom prst="rect">
-              <a:avLst/>
-            </a:prstGeom>
-            <a:noFill/>
-            <a:ln/>
-          </p:spPr>
-          <p:txBody>
-            <a:bodyPr wrap="square" rtlCol="0" anchor="ctr"/>
-            <a:lstStyle/>
-            <a:p>
-              <a:pPr marL="0" indent="0">
-                <a:buNone/>
-              </a:pPr>
-              <a:r>
-                <a:rPr lang="en-US" sz="1000" i="1" dirty="0">
-                  <a:solidFill>
-                    <a:srgbClr val="E84545"/>
-                  </a:solidFill>
-                  <a:latin typeface="Calibri" pitchFamily="34" charset="0"/>
-                  <a:ea typeface="Calibri" pitchFamily="34" charset="-122"/>
-                  <a:cs typeface="Calibri" pitchFamily="34" charset="-120"/>
-                </a:rPr>
-                <a:t>Dilated Convolutions</a:t>
-              </a:r>
-              <a:endParaRPr lang="en-US" sz="1000" dirty="0"/>
-            </a:p>
-          </p:txBody>
-        </p:sp>
-        <p:sp>
-          <p:nvSpPr>
-            <p:cNvPr id="10" name="Shape 7"/>
-            <p:cNvSpPr/>
-            <p:nvPr/>
-          </p:nvSpPr>
-          <p:spPr>
-            <a:xfrm>
-              <a:off x="411480" y="2148839"/>
-              <a:ext cx="2450666" cy="45719"/>
-            </a:xfrm>
-            <a:prstGeom prst="rect">
-              <a:avLst/>
-            </a:prstGeom>
-            <a:solidFill>
-              <a:srgbClr val="E84545"/>
-            </a:solidFill>
-            <a:ln/>
-          </p:spPr>
-          <p:txBody>
-            <a:bodyPr/>
-            <a:lstStyle/>
-            <a:p>
-              <a:endParaRPr lang="en-MT"/>
-            </a:p>
-          </p:txBody>
-        </p:sp>
-        <p:sp>
-          <p:nvSpPr>
-            <p:cNvPr id="11" name="Text 8"/>
-            <p:cNvSpPr/>
-            <p:nvPr/>
-          </p:nvSpPr>
-          <p:spPr>
-            <a:xfrm>
-              <a:off x="411480" y="2240280"/>
-              <a:ext cx="2383759" cy="2514600"/>
-            </a:xfrm>
-            <a:prstGeom prst="rect">
-              <a:avLst/>
-            </a:prstGeom>
-            <a:noFill/>
-            <a:ln/>
-          </p:spPr>
-          <p:txBody>
-            <a:bodyPr wrap="square" rtlCol="0" anchor="t"/>
-            <a:lstStyle/>
-            <a:p>
-              <a:pPr marL="0" indent="0">
-                <a:buNone/>
-              </a:pPr>
-              <a:r>
-                <a:rPr lang="en-US" sz="1100" dirty="0">
-                  <a:solidFill>
-                    <a:srgbClr val="E8F4F8"/>
-                  </a:solidFill>
-                  <a:latin typeface="Calibri" pitchFamily="34" charset="0"/>
-                  <a:ea typeface="Calibri" pitchFamily="34" charset="-122"/>
-                  <a:cs typeface="Calibri" pitchFamily="34" charset="-120"/>
-                </a:rPr>
-                <a:t>Dilated kernels (d=2,4,8) give the CNN a wide-angle view of the road without downsampling. The same 3×3 filter effectively sees a 15×15 area — crucial for detecting distant pedestrians while preserving lane-marking detail.</a:t>
-              </a:r>
-              <a:endParaRPr lang="en-US" sz="1100" dirty="0"/>
-            </a:p>
-          </p:txBody>
-        </p:sp>
-      </p:grpSp>
-      <p:sp>
-        <p:nvSpPr>
-          <p:cNvPr id="12" name="Shape 9"/>
-          <p:cNvSpPr/>
-          <p:nvPr/>
-        </p:nvSpPr>
-        <p:spPr>
-          <a:xfrm>
-            <a:off x="3246120" y="1417320"/>
-            <a:ext cx="2697480" cy="3474720"/>
-          </a:xfrm>
-          <a:prstGeom prst="rect">
-            <a:avLst/>
-          </a:prstGeom>
-          <a:solidFill>
-            <a:srgbClr val="122040"/>
-          </a:solidFill>
-          <a:ln/>
-          <a:effectLst>
-            <a:outerShdw blurRad="101600" dist="38100" dir="8100000" algn="bl" rotWithShape="0">
-              <a:srgbClr val="000000">
-                <a:alpha val="18000"/>
-              </a:srgbClr>
-            </a:outerShdw>
-          </a:effectLst>
-        </p:spPr>
-        <p:txBody>
-          <a:bodyPr/>
-          <a:lstStyle/>
-          <a:p>
-            <a:endParaRPr lang="en-MT"/>
-          </a:p>
-        </p:txBody>
-      </p:sp>
-      <p:sp>
-        <p:nvSpPr>
-          <p:cNvPr id="13" name="Shape 10"/>
-          <p:cNvSpPr/>
-          <p:nvPr/>
-        </p:nvSpPr>
-        <p:spPr>
-          <a:xfrm>
-            <a:off x="3246120" y="1417320"/>
-            <a:ext cx="2697480" cy="82296"/>
-          </a:xfrm>
-          <a:prstGeom prst="rect">
-            <a:avLst/>
-          </a:prstGeom>
-          <a:solidFill>
-            <a:srgbClr val="00A896"/>
-          </a:solidFill>
-          <a:ln/>
-        </p:spPr>
-        <p:txBody>
-          <a:bodyPr/>
-          <a:lstStyle/>
-          <a:p>
-            <a:endParaRPr lang="en-MT"/>
-          </a:p>
-        </p:txBody>
-      </p:sp>
-      <p:pic>
-        <p:nvPicPr>
-          <p:cNvPr id="14" name="Image 1" descr="preencoded.png"/>
-          <p:cNvPicPr>
-            <a:picLocks noChangeAspect="1"/>
-          </p:cNvPicPr>
-          <p:nvPr/>
-        </p:nvPicPr>
-        <p:blipFill>
-          <a:blip r:embed="rId4"/>
-          <a:stretch>
-            <a:fillRect/>
-          </a:stretch>
-        </p:blipFill>
-        <p:spPr>
-          <a:xfrm>
-            <a:off x="3419891" y="1613915"/>
-            <a:ext cx="411480" cy="411480"/>
-          </a:xfrm>
-          <a:prstGeom prst="rect">
-            <a:avLst/>
-          </a:prstGeom>
-        </p:spPr>
-      </p:pic>
-      <p:sp>
-        <p:nvSpPr>
-          <p:cNvPr id="15" name="Text 11"/>
-          <p:cNvSpPr/>
-          <p:nvPr/>
-        </p:nvSpPr>
-        <p:spPr>
-          <a:xfrm>
-            <a:off x="3840480" y="1554480"/>
-            <a:ext cx="2103120" cy="274320"/>
-          </a:xfrm>
-          <a:prstGeom prst="rect">
-            <a:avLst/>
-          </a:prstGeom>
-          <a:noFill/>
-          <a:ln/>
-        </p:spPr>
-        <p:txBody>
-          <a:bodyPr wrap="square" rtlCol="0" anchor="ctr"/>
-          <a:lstStyle/>
-          <a:p>
-            <a:pPr marL="0" indent="0">
-              <a:buNone/>
-            </a:pPr>
-            <a:r>
-              <a:rPr lang="en-US" sz="1300" b="1" dirty="0">
-                <a:solidFill>
-                  <a:srgbClr val="FFFFFF"/>
-                </a:solidFill>
-                <a:latin typeface="Calibri" pitchFamily="34" charset="0"/>
-                <a:ea typeface="Calibri" pitchFamily="34" charset="-122"/>
-                <a:cs typeface="Calibri" pitchFamily="34" charset="-120"/>
-              </a:rPr>
-              <a:t>Medical Imaging</a:t>
-            </a:r>
-            <a:endParaRPr lang="en-US" sz="1300" dirty="0"/>
-          </a:p>
-        </p:txBody>
-      </p:sp>
-      <p:sp>
-        <p:nvSpPr>
-          <p:cNvPr id="16" name="Text 12"/>
-          <p:cNvSpPr/>
-          <p:nvPr/>
-        </p:nvSpPr>
-        <p:spPr>
-          <a:xfrm>
-            <a:off x="3840480" y="1847088"/>
-            <a:ext cx="2103120" cy="228600"/>
-          </a:xfrm>
-          <a:prstGeom prst="rect">
-            <a:avLst/>
-          </a:prstGeom>
-          <a:noFill/>
-          <a:ln/>
-        </p:spPr>
-        <p:txBody>
-          <a:bodyPr wrap="square" rtlCol="0" anchor="ctr"/>
-          <a:lstStyle/>
-          <a:p>
-            <a:pPr marL="0" indent="0">
-              <a:buNone/>
-            </a:pPr>
-            <a:r>
-              <a:rPr lang="en-US" sz="1000" i="1" dirty="0">
-                <a:solidFill>
-                  <a:srgbClr val="00A896"/>
-                </a:solidFill>
-                <a:latin typeface="Calibri" pitchFamily="34" charset="0"/>
-                <a:ea typeface="Calibri" pitchFamily="34" charset="-122"/>
-                <a:cs typeface="Calibri" pitchFamily="34" charset="-120"/>
-              </a:rPr>
-              <a:t>Sobel + U-Net</a:t>
-            </a:r>
-            <a:endParaRPr lang="en-US" sz="1000" dirty="0"/>
-          </a:p>
-        </p:txBody>
-      </p:sp>
-      <p:sp>
-        <p:nvSpPr>
-          <p:cNvPr id="17" name="Shape 13"/>
-          <p:cNvSpPr/>
-          <p:nvPr/>
-        </p:nvSpPr>
-        <p:spPr>
-          <a:xfrm>
-            <a:off x="3383280" y="2148839"/>
-            <a:ext cx="2422788" cy="45719"/>
-          </a:xfrm>
-          <a:prstGeom prst="rect">
-            <a:avLst/>
-          </a:prstGeom>
-          <a:solidFill>
-            <a:srgbClr val="00A896"/>
-          </a:solidFill>
-          <a:ln/>
-        </p:spPr>
-        <p:txBody>
-          <a:bodyPr/>
-          <a:lstStyle/>
-          <a:p>
-            <a:endParaRPr lang="en-MT"/>
-          </a:p>
-        </p:txBody>
-      </p:sp>
-      <p:sp>
-        <p:nvSpPr>
-          <p:cNvPr id="18" name="Text 14"/>
-          <p:cNvSpPr/>
-          <p:nvPr/>
-        </p:nvSpPr>
-        <p:spPr>
-          <a:xfrm>
-            <a:off x="3383280" y="2240280"/>
-            <a:ext cx="2288974" cy="2514600"/>
-          </a:xfrm>
-          <a:prstGeom prst="rect">
-            <a:avLst/>
-          </a:prstGeom>
-          <a:noFill/>
-          <a:ln/>
-        </p:spPr>
-        <p:txBody>
-          <a:bodyPr wrap="square" rtlCol="0" anchor="t"/>
-          <a:lstStyle/>
-          <a:p>
-            <a:pPr marL="0" indent="0">
-              <a:buNone/>
-            </a:pPr>
-            <a:r>
-              <a:rPr lang="en-US" sz="1100" dirty="0">
-                <a:solidFill>
-                  <a:srgbClr val="E8F4F8"/>
-                </a:solidFill>
-                <a:latin typeface="Calibri" pitchFamily="34" charset="0"/>
-                <a:ea typeface="Calibri" pitchFamily="34" charset="-122"/>
-                <a:cs typeface="Calibri" pitchFamily="34" charset="-120"/>
-              </a:rPr>
-              <a:t>Radiologists use Sobel-seeded CNNs to segment tumour boundaries in MRI scans. The Laplacian kernel highlights micro-textures invisible to the human eye, enabling earlier cancer detection at sub-millimetre precision.</a:t>
-            </a:r>
-            <a:endParaRPr lang="en-US" sz="1100" dirty="0"/>
-          </a:p>
-        </p:txBody>
-      </p:sp>
-      <p:sp>
-        <p:nvSpPr>
-          <p:cNvPr id="19" name="Shape 15"/>
-          <p:cNvSpPr/>
-          <p:nvPr/>
-        </p:nvSpPr>
-        <p:spPr>
-          <a:xfrm>
-            <a:off x="6217920" y="1417320"/>
-            <a:ext cx="2697480" cy="3474720"/>
-          </a:xfrm>
-          <a:prstGeom prst="rect">
-            <a:avLst/>
-          </a:prstGeom>
-          <a:solidFill>
-            <a:srgbClr val="122040"/>
-          </a:solidFill>
-          <a:ln/>
-          <a:effectLst>
-            <a:outerShdw blurRad="101600" dist="38100" dir="8100000" algn="bl" rotWithShape="0">
-              <a:srgbClr val="000000">
-                <a:alpha val="18000"/>
-              </a:srgbClr>
-            </a:outerShdw>
-          </a:effectLst>
-        </p:spPr>
-        <p:txBody>
-          <a:bodyPr/>
-          <a:lstStyle/>
-          <a:p>
-            <a:endParaRPr lang="en-MT"/>
-          </a:p>
-        </p:txBody>
-      </p:sp>
-      <p:sp>
-        <p:nvSpPr>
-          <p:cNvPr id="20" name="Shape 16"/>
-          <p:cNvSpPr/>
-          <p:nvPr/>
-        </p:nvSpPr>
-        <p:spPr>
-          <a:xfrm>
-            <a:off x="6217920" y="1417320"/>
-            <a:ext cx="2697480" cy="82296"/>
-          </a:xfrm>
-          <a:prstGeom prst="rect">
-            <a:avLst/>
-          </a:prstGeom>
-          <a:solidFill>
-            <a:srgbClr val="F5A623"/>
-          </a:solidFill>
-          <a:ln/>
-        </p:spPr>
-        <p:txBody>
-          <a:bodyPr/>
-          <a:lstStyle/>
-          <a:p>
-            <a:endParaRPr lang="en-MT"/>
-          </a:p>
-        </p:txBody>
-      </p:sp>
-      <p:pic>
-        <p:nvPicPr>
-          <p:cNvPr id="21" name="Image 2" descr="preencoded.png"/>
-          <p:cNvPicPr>
-            <a:picLocks noChangeAspect="1"/>
-          </p:cNvPicPr>
-          <p:nvPr/>
-        </p:nvPicPr>
-        <p:blipFill>
-          <a:blip r:embed="rId5"/>
-          <a:stretch>
-            <a:fillRect/>
-          </a:stretch>
-        </p:blipFill>
-        <p:spPr>
-          <a:xfrm>
-            <a:off x="6364818" y="1600199"/>
-            <a:ext cx="411480" cy="411480"/>
-          </a:xfrm>
-          <a:prstGeom prst="rect">
-            <a:avLst/>
-          </a:prstGeom>
-        </p:spPr>
-      </p:pic>
-      <p:sp>
-        <p:nvSpPr>
-          <p:cNvPr id="22" name="Text 17"/>
-          <p:cNvSpPr/>
-          <p:nvPr/>
-        </p:nvSpPr>
-        <p:spPr>
-          <a:xfrm>
-            <a:off x="6812280" y="1554480"/>
-            <a:ext cx="2103120" cy="384048"/>
-          </a:xfrm>
-          <a:prstGeom prst="rect">
-            <a:avLst/>
-          </a:prstGeom>
-          <a:noFill/>
-          <a:ln/>
-        </p:spPr>
-        <p:txBody>
-          <a:bodyPr wrap="square" rtlCol="0" anchor="ctr"/>
-          <a:lstStyle/>
-          <a:p>
-            <a:pPr marL="0" indent="0">
-              <a:buNone/>
-            </a:pPr>
-            <a:r>
-              <a:rPr lang="en-US" sz="1300" b="1" dirty="0">
-                <a:solidFill>
-                  <a:srgbClr val="FFFFFF"/>
-                </a:solidFill>
-                <a:latin typeface="Calibri" pitchFamily="34" charset="0"/>
-                <a:ea typeface="Calibri" pitchFamily="34" charset="-122"/>
-                <a:cs typeface="Calibri" pitchFamily="34" charset="-120"/>
-              </a:rPr>
-              <a:t>Google Photos (MobileNet)</a:t>
-            </a:r>
-            <a:endParaRPr lang="en-US" sz="1300" dirty="0"/>
-          </a:p>
-        </p:txBody>
-      </p:sp>
-      <p:sp>
-        <p:nvSpPr>
-          <p:cNvPr id="23" name="Text 18"/>
-          <p:cNvSpPr/>
-          <p:nvPr/>
-        </p:nvSpPr>
-        <p:spPr>
-          <a:xfrm>
-            <a:off x="6812280" y="1847088"/>
-            <a:ext cx="2103120" cy="228600"/>
-          </a:xfrm>
-          <a:prstGeom prst="rect">
-            <a:avLst/>
-          </a:prstGeom>
-          <a:noFill/>
-          <a:ln/>
-        </p:spPr>
-        <p:txBody>
-          <a:bodyPr wrap="square" rtlCol="0" anchor="ctr"/>
-          <a:lstStyle/>
-          <a:p>
-            <a:pPr marL="0" indent="0">
-              <a:buNone/>
-            </a:pPr>
-            <a:r>
-              <a:rPr lang="en-US" sz="1000" i="1" dirty="0">
-                <a:solidFill>
-                  <a:srgbClr val="F5A623"/>
-                </a:solidFill>
-                <a:latin typeface="Calibri" pitchFamily="34" charset="0"/>
-                <a:ea typeface="Calibri" pitchFamily="34" charset="-122"/>
-                <a:cs typeface="Calibri" pitchFamily="34" charset="-120"/>
-              </a:rPr>
-              <a:t>Depthwise Separable</a:t>
-            </a:r>
-            <a:endParaRPr lang="en-US" sz="1000" dirty="0"/>
-          </a:p>
-        </p:txBody>
-      </p:sp>
-      <p:sp>
-        <p:nvSpPr>
-          <p:cNvPr id="24" name="Shape 19"/>
-          <p:cNvSpPr/>
-          <p:nvPr/>
-        </p:nvSpPr>
-        <p:spPr>
-          <a:xfrm>
-            <a:off x="6355079" y="2148839"/>
-            <a:ext cx="2423161" cy="45719"/>
-          </a:xfrm>
-          <a:prstGeom prst="rect">
-            <a:avLst/>
-          </a:prstGeom>
-          <a:solidFill>
-            <a:srgbClr val="F5A623"/>
-          </a:solidFill>
-          <a:ln/>
-        </p:spPr>
-        <p:txBody>
-          <a:bodyPr/>
-          <a:lstStyle/>
-          <a:p>
-            <a:endParaRPr lang="en-MT"/>
-          </a:p>
-        </p:txBody>
-      </p:sp>
-      <p:sp>
-        <p:nvSpPr>
-          <p:cNvPr id="25" name="Text 20"/>
-          <p:cNvSpPr/>
-          <p:nvPr/>
-        </p:nvSpPr>
-        <p:spPr>
-          <a:xfrm>
-            <a:off x="6355080" y="2240280"/>
-            <a:ext cx="2377440" cy="2514600"/>
-          </a:xfrm>
-          <a:prstGeom prst="rect">
-            <a:avLst/>
-          </a:prstGeom>
-          <a:noFill/>
-          <a:ln/>
-        </p:spPr>
-        <p:txBody>
-          <a:bodyPr wrap="square" rtlCol="0" anchor="t"/>
-          <a:lstStyle/>
-          <a:p>
-            <a:r>
-              <a:rPr lang="en-US" sz="1100" dirty="0" err="1">
-                <a:solidFill>
-                  <a:srgbClr val="E8F4F8"/>
-                </a:solidFill>
-                <a:latin typeface="Calibri" pitchFamily="34" charset="0"/>
-                <a:ea typeface="Calibri" pitchFamily="34" charset="-122"/>
-                <a:cs typeface="Calibri" pitchFamily="34" charset="-120"/>
-              </a:rPr>
-              <a:t>MobileNets</a:t>
-            </a:r>
-            <a:r>
-              <a:rPr lang="en-US" sz="1100" dirty="0">
-                <a:solidFill>
-                  <a:srgbClr val="E8F4F8"/>
-                </a:solidFill>
-                <a:latin typeface="Calibri" pitchFamily="34" charset="0"/>
-                <a:ea typeface="Calibri" pitchFamily="34" charset="-122"/>
-                <a:cs typeface="Calibri" pitchFamily="34" charset="-120"/>
-              </a:rPr>
-              <a:t> use a smaller version of a standard CNN, but by using </a:t>
-            </a:r>
-            <a:r>
-              <a:rPr lang="en-US" sz="1100" dirty="0" err="1">
-                <a:solidFill>
-                  <a:srgbClr val="E8F4F8"/>
-                </a:solidFill>
-                <a:latin typeface="Calibri" pitchFamily="34" charset="0"/>
-                <a:ea typeface="Calibri" pitchFamily="34" charset="-122"/>
-                <a:cs typeface="Calibri" pitchFamily="34" charset="-120"/>
-              </a:rPr>
-              <a:t>depthwise</a:t>
-            </a:r>
-            <a:r>
-              <a:rPr lang="en-US" sz="1100" dirty="0">
-                <a:solidFill>
-                  <a:srgbClr val="E8F4F8"/>
-                </a:solidFill>
-                <a:latin typeface="Calibri" pitchFamily="34" charset="0"/>
-                <a:ea typeface="Calibri" pitchFamily="34" charset="-122"/>
-                <a:cs typeface="Calibri" pitchFamily="34" charset="-120"/>
-              </a:rPr>
-              <a:t> separable convolution — separating spatial filtering from channel mixing. The result: 8× fewer calculations and real-time classification of 1B+ photos daily without draining battery.</a:t>
-            </a:r>
-            <a:endParaRPr lang="en-US" sz="1100" dirty="0"/>
           </a:p>
         </p:txBody>
       </p:sp>

</xml_diff>